<commit_message>
remiing files for Module1
</commit_message>
<xml_diff>
--- a/Module2Youtube/Final/Copilot_RAG_Agent_YouTube_Lecture.pptx
+++ b/Module2Youtube/Final/Copilot_RAG_Agent_YouTube_Lecture.pptx
@@ -13,9 +13,12 @@
     <p:sldId id="261" r:id="rId7"/>
     <p:sldId id="262" r:id="rId8"/>
     <p:sldId id="263" r:id="rId9"/>
+    <p:sldId id="264" r:id="rId10"/>
+    <p:sldId id="265" r:id="rId11"/>
+    <p:sldId id="266" r:id="rId12"/>
   </p:sldIdLst>
   <p:notesMasterIdLst>
-    <p:notesMasterId r:id="rId10"/>
+    <p:notesMasterId r:id="rId13"/>
   </p:notesMasterIdLst>
   <p:sldSz cx="9144000" cy="5143500"/>
   <p:notesSz cx="5143500" cy="9144000"/>
@@ -551,6 +554,182 @@
 </p:notes>
 </file>
 
+<file path=ppt/notesSlides/notesSlide10.xml><?xml version="1.0" encoding="utf-8"?>
+<p:notes xmlns:a="http://schemas.openxmlformats.org/drawingml/2006/main" xmlns:r="http://schemas.openxmlformats.org/officeDocument/2006/relationships" xmlns:p="http://schemas.openxmlformats.org/presentationml/2006/main">
+  <p:cSld>
+    <p:spTree>
+      <p:nvGrpSpPr>
+        <p:cNvPr id="1" name=""/>
+        <p:cNvGrpSpPr/>
+        <p:nvPr/>
+      </p:nvGrpSpPr>
+      <p:grpSpPr>
+        <a:xfrm>
+          <a:off x="0" y="0"/>
+          <a:ext cx="0" cy="0"/>
+          <a:chOff x="0" y="0"/>
+          <a:chExt cx="0" cy="0"/>
+        </a:xfrm>
+      </p:grpSpPr>
+      <p:sp>
+        <p:nvSpPr>
+          <p:cNvPr id="2" name="Slide Image Placeholder 1"/>
+          <p:cNvSpPr>
+            <a:spLocks noGrp="1" noRot="1" noChangeAspect="1"/>
+          </p:cNvSpPr>
+          <p:nvPr>
+            <p:ph type="sldImg"/>
+          </p:nvPr>
+        </p:nvSpPr>
+        <p:spPr/>
+      </p:sp>
+      <p:sp>
+        <p:nvSpPr>
+          <p:cNvPr id="3" name="Notes Placeholder 2"/>
+          <p:cNvSpPr>
+            <a:spLocks noGrp="1"/>
+          </p:cNvSpPr>
+          <p:nvPr>
+            <p:ph type="body" idx="1"/>
+          </p:nvPr>
+        </p:nvSpPr>
+        <p:spPr/>
+        <p:txBody>
+          <a:bodyPr/>
+          <a:lstStyle/>
+          <a:p>
+            <a:r>
+              <a:rPr lang="en-US" dirty="0"/>
+              <a:t>Switch to Copilot Studio Test pane. Show citations. Use real behaviour and never edit answers. Fallback: rehearsal screenshots. Return to the slides for failure modes.</a:t>
+            </a:r>
+            <a:endParaRPr lang="en-US" dirty="0"/>
+          </a:p>
+        </p:txBody>
+      </p:sp>
+      <p:sp>
+        <p:nvSpPr>
+          <p:cNvPr id="4" name="Slide Number Placeholder 3"/>
+          <p:cNvSpPr>
+            <a:spLocks noGrp="1"/>
+          </p:cNvSpPr>
+          <p:nvPr>
+            <p:ph type="sldNum" sz="quarter" idx="10"/>
+          </p:nvPr>
+        </p:nvSpPr>
+        <p:spPr/>
+        <p:txBody>
+          <a:bodyPr/>
+          <a:lstStyle/>
+          <a:p>
+            <a:fld id="{F7021451-1387-4CA6-816F-3879F97B5CBC}" type="slidenum">
+              <a:rPr lang="en-US"/>
+              <a:t>10</a:t>
+            </a:fld>
+            <a:endParaRPr lang="en-US"/>
+          </a:p>
+        </p:txBody>
+      </p:sp>
+    </p:spTree>
+    <p:extLst>
+      <p:ext uri="{BB962C8B-B14F-4D97-AF65-F5344CB8AC3E}">
+        <p14:creationId xmlns:p14="http://schemas.microsoft.com/office/powerpoint/2010/main" val="1024086991"/>
+      </p:ext>
+    </p:extLst>
+  </p:cSld>
+  <p:clrMapOvr>
+    <a:masterClrMapping/>
+  </p:clrMapOvr>
+</p:notes>
+</file>
+
+<file path=ppt/notesSlides/notesSlide11.xml><?xml version="1.0" encoding="utf-8"?>
+<p:notes xmlns:a="http://schemas.openxmlformats.org/drawingml/2006/main" xmlns:r="http://schemas.openxmlformats.org/officeDocument/2006/relationships" xmlns:p="http://schemas.openxmlformats.org/presentationml/2006/main">
+  <p:cSld>
+    <p:spTree>
+      <p:nvGrpSpPr>
+        <p:cNvPr id="1" name=""/>
+        <p:cNvGrpSpPr/>
+        <p:nvPr/>
+      </p:nvGrpSpPr>
+      <p:grpSpPr>
+        <a:xfrm>
+          <a:off x="0" y="0"/>
+          <a:ext cx="0" cy="0"/>
+          <a:chOff x="0" y="0"/>
+          <a:chExt cx="0" cy="0"/>
+        </a:xfrm>
+      </p:grpSpPr>
+      <p:sp>
+        <p:nvSpPr>
+          <p:cNvPr id="2" name="Slide Image Placeholder 1"/>
+          <p:cNvSpPr>
+            <a:spLocks noGrp="1" noRot="1" noChangeAspect="1"/>
+          </p:cNvSpPr>
+          <p:nvPr>
+            <p:ph type="sldImg"/>
+          </p:nvPr>
+        </p:nvSpPr>
+        <p:spPr/>
+      </p:sp>
+      <p:sp>
+        <p:nvSpPr>
+          <p:cNvPr id="3" name="Notes Placeholder 2"/>
+          <p:cNvSpPr>
+            <a:spLocks noGrp="1"/>
+          </p:cNvSpPr>
+          <p:nvPr>
+            <p:ph type="body" idx="1"/>
+          </p:nvPr>
+        </p:nvSpPr>
+        <p:spPr/>
+        <p:txBody>
+          <a:bodyPr/>
+          <a:lstStyle/>
+          <a:p>
+            <a:r>
+              <a:rPr lang="en-US" dirty="0"/>
+              <a:t>Four failure modes, then three takeaways. Teaser: topics and triggers next. Closing: I'm Mayank Chugh, thank you for watching! Please Like, Share, and Subscribe. Take care!</a:t>
+            </a:r>
+            <a:endParaRPr lang="en-US" dirty="0"/>
+          </a:p>
+        </p:txBody>
+      </p:sp>
+      <p:sp>
+        <p:nvSpPr>
+          <p:cNvPr id="4" name="Slide Number Placeholder 3"/>
+          <p:cNvSpPr>
+            <a:spLocks noGrp="1"/>
+          </p:cNvSpPr>
+          <p:nvPr>
+            <p:ph type="sldNum" sz="quarter" idx="10"/>
+          </p:nvPr>
+        </p:nvSpPr>
+        <p:spPr/>
+        <p:txBody>
+          <a:bodyPr/>
+          <a:lstStyle/>
+          <a:p>
+            <a:fld id="{F7021451-1387-4CA6-816F-3879F97B5CBC}" type="slidenum">
+              <a:rPr lang="en-US"/>
+              <a:t>11</a:t>
+            </a:fld>
+            <a:endParaRPr lang="en-US"/>
+          </a:p>
+        </p:txBody>
+      </p:sp>
+    </p:spTree>
+    <p:extLst>
+      <p:ext uri="{BB962C8B-B14F-4D97-AF65-F5344CB8AC3E}">
+        <p14:creationId xmlns:p14="http://schemas.microsoft.com/office/powerpoint/2010/main" val="1024086991"/>
+      </p:ext>
+    </p:extLst>
+  </p:cSld>
+  <p:clrMapOvr>
+    <a:masterClrMapping/>
+  </p:clrMapOvr>
+</p:notes>
+</file>
+
 <file path=ppt/notesSlides/notesSlide2.xml><?xml version="1.0" encoding="utf-8"?>
 <p:notes xmlns:a="http://schemas.openxmlformats.org/drawingml/2006/main" xmlns:r="http://schemas.openxmlformats.org/officeDocument/2006/relationships" xmlns:p="http://schemas.openxmlformats.org/presentationml/2006/main">
   <p:cSld>
@@ -949,7 +1128,7 @@
           <a:p>
             <a:r>
               <a:rPr lang="en-US" dirty="0"/>
-              <a:t>Create the agent first, then add knowledge. Let both sources reach Ready. Mention Bing indexing, two URL levels, no login sites. The FAQ is sample content: say so.</a:t>
+              <a:t>Switch to Copilot Studio and follow these steps. Validate labels first: UI may differ by account/version. Show the web search setting on camera. Return to the slides when the agent is created.</a:t>
             </a:r>
             <a:endParaRPr lang="en-US" dirty="0"/>
           </a:p>
@@ -1037,7 +1216,7 @@
           <a:p>
             <a:r>
               <a:rPr lang="en-US" dirty="0"/>
-              <a:t>Run the four tests from the Demo Runbook. Show citations. Use real behaviour; never edit answers. Fallback: rehearsal screenshots.</a:t>
+              <a:t>Create the agent first, then add knowledge. Let both sources reach Ready. Mention Bing indexing, two URL levels, no login sites. The FAQ is sample content: say so.</a:t>
             </a:r>
             <a:endParaRPr lang="en-US" dirty="0"/>
           </a:p>
@@ -1125,7 +1304,7 @@
           <a:p>
             <a:r>
               <a:rPr lang="en-US" dirty="0"/>
-              <a:t>Four failure modes, then three takeaways. Teaser: topics and triggers next. Closing: I'm Mayank Chugh, thank you for watching! Please Like, Share, and Subscribe. Take care!</a:t>
+              <a:t>Switch to Copilot Studio. If the website is not Ready, say so, continue with the document, and show the rehearsal screenshot later. Return to the slides afterwards.</a:t>
             </a:r>
             <a:endParaRPr lang="en-US" dirty="0"/>
           </a:p>
@@ -1149,6 +1328,94 @@
             <a:fld id="{F7021451-1387-4CA6-816F-3879F97B5CBC}" type="slidenum">
               <a:rPr lang="en-US"/>
               <a:t>8</a:t>
+            </a:fld>
+            <a:endParaRPr lang="en-US"/>
+          </a:p>
+        </p:txBody>
+      </p:sp>
+    </p:spTree>
+    <p:extLst>
+      <p:ext uri="{BB962C8B-B14F-4D97-AF65-F5344CB8AC3E}">
+        <p14:creationId xmlns:p14="http://schemas.microsoft.com/office/powerpoint/2010/main" val="1024086991"/>
+      </p:ext>
+    </p:extLst>
+  </p:cSld>
+  <p:clrMapOvr>
+    <a:masterClrMapping/>
+  </p:clrMapOvr>
+</p:notes>
+</file>
+
+<file path=ppt/notesSlides/notesSlide9.xml><?xml version="1.0" encoding="utf-8"?>
+<p:notes xmlns:a="http://schemas.openxmlformats.org/drawingml/2006/main" xmlns:r="http://schemas.openxmlformats.org/officeDocument/2006/relationships" xmlns:p="http://schemas.openxmlformats.org/presentationml/2006/main">
+  <p:cSld>
+    <p:spTree>
+      <p:nvGrpSpPr>
+        <p:cNvPr id="1" name=""/>
+        <p:cNvGrpSpPr/>
+        <p:nvPr/>
+      </p:nvGrpSpPr>
+      <p:grpSpPr>
+        <a:xfrm>
+          <a:off x="0" y="0"/>
+          <a:ext cx="0" cy="0"/>
+          <a:chOff x="0" y="0"/>
+          <a:chExt cx="0" cy="0"/>
+        </a:xfrm>
+      </p:grpSpPr>
+      <p:sp>
+        <p:nvSpPr>
+          <p:cNvPr id="2" name="Slide Image Placeholder 1"/>
+          <p:cNvSpPr>
+            <a:spLocks noGrp="1" noRot="1" noChangeAspect="1"/>
+          </p:cNvSpPr>
+          <p:nvPr>
+            <p:ph type="sldImg"/>
+          </p:nvPr>
+        </p:nvSpPr>
+        <p:spPr/>
+      </p:sp>
+      <p:sp>
+        <p:nvSpPr>
+          <p:cNvPr id="3" name="Notes Placeholder 2"/>
+          <p:cNvSpPr>
+            <a:spLocks noGrp="1"/>
+          </p:cNvSpPr>
+          <p:nvPr>
+            <p:ph type="body" idx="1"/>
+          </p:nvPr>
+        </p:nvSpPr>
+        <p:spPr/>
+        <p:txBody>
+          <a:bodyPr/>
+          <a:lstStyle/>
+          <a:p>
+            <a:r>
+              <a:rPr lang="en-US" dirty="0"/>
+              <a:t>Run the four tests from the Demo Runbook. Show citations. Use real behaviour; never edit answers. Fallback: rehearsal screenshots.</a:t>
+            </a:r>
+            <a:endParaRPr lang="en-US" dirty="0"/>
+          </a:p>
+        </p:txBody>
+      </p:sp>
+      <p:sp>
+        <p:nvSpPr>
+          <p:cNvPr id="4" name="Slide Number Placeholder 3"/>
+          <p:cNvSpPr>
+            <a:spLocks noGrp="1"/>
+          </p:cNvSpPr>
+          <p:nvPr>
+            <p:ph type="sldNum" sz="quarter" idx="10"/>
+          </p:nvPr>
+        </p:nvSpPr>
+        <p:spPr/>
+        <p:txBody>
+          <a:bodyPr/>
+          <a:lstStyle/>
+          <a:p>
+            <a:fld id="{F7021451-1387-4CA6-816F-3879F97B5CBC}" type="slidenum">
+              <a:rPr lang="en-US"/>
+              <a:t>9</a:t>
             </a:fld>
             <a:endParaRPr lang="en-US"/>
           </a:p>
@@ -1662,6 +1929,1257 @@
 </p:sld>
 </file>
 
+<file path=ppt/slides/slide10.xml><?xml version="1.0" encoding="utf-8"?>
+<p:sld xmlns:a="http://schemas.openxmlformats.org/drawingml/2006/main" xmlns:r="http://schemas.openxmlformats.org/officeDocument/2006/relationships" xmlns:p="http://schemas.openxmlformats.org/presentationml/2006/main">
+  <p:cSld name="Slide 10">
+    <p:bg>
+      <p:bgPr>
+        <a:solidFill>
+          <a:srgbClr val="0A1628"/>
+        </a:solidFill>
+      </p:bgPr>
+    </p:bg>
+    <p:spTree>
+      <p:nvGrpSpPr>
+        <p:cNvPr id="1" name=""/>
+        <p:cNvGrpSpPr/>
+        <p:nvPr/>
+      </p:nvGrpSpPr>
+      <p:grpSpPr>
+        <a:xfrm>
+          <a:off x="0" y="0"/>
+          <a:ext cx="0" cy="0"/>
+          <a:chOff x="0" y="0"/>
+          <a:chExt cx="0" cy="0"/>
+        </a:xfrm>
+      </p:grpSpPr>
+      <p:sp>
+        <p:nvSpPr>
+          <p:cNvPr id="2" name="Text 0"/>
+          <p:cNvSpPr txBox="1"/>
+          <p:nvPr/>
+        </p:nvSpPr>
+        <p:spPr>
+          <a:xfrm>
+            <a:off x="457200" y="274320"/>
+            <a:ext cx="8229600" cy="548640"/>
+          </a:xfrm>
+          <a:prstGeom prst="rect">
+            <a:avLst/>
+          </a:prstGeom>
+          <a:noFill/>
+          <a:ln/>
+        </p:spPr>
+        <p:txBody>
+          <a:bodyPr wrap="square" lIns="0" tIns="0" rIns="0" bIns="0" rtlCol="0" anchor="ctr"/>
+          <a:lstStyle/>
+          <a:p>
+            <a:pPr indent="0" marL="0">
+              <a:buNone/>
+            </a:pPr>
+            <a:r>
+              <a:rPr lang="en-US" sz="2800" b="1" dirty="0">
+                <a:solidFill>
+                  <a:srgbClr val="FFFFFF"/>
+                </a:solidFill>
+                <a:latin typeface="Calibri" pitchFamily="34" charset="0"/>
+                <a:ea typeface="Calibri" pitchFamily="34" charset="-122"/>
+                <a:cs typeface="Calibri" pitchFamily="34" charset="-120"/>
+              </a:rPr>
+              <a:t>Demo 3: Run the tests</a:t>
+            </a:r>
+            <a:endParaRPr lang="en-US" sz="2800" dirty="0"/>
+          </a:p>
+        </p:txBody>
+      </p:sp>
+      <p:sp>
+        <p:nvSpPr>
+          <p:cNvPr id="3" name="Shape 1"/>
+          <p:cNvSpPr/>
+          <p:nvPr/>
+        </p:nvSpPr>
+        <p:spPr>
+          <a:xfrm>
+            <a:off x="457200" y="868680"/>
+            <a:ext cx="1097280" cy="54864"/>
+          </a:xfrm>
+          <a:prstGeom prst="rect">
+            <a:avLst/>
+          </a:prstGeom>
+          <a:solidFill>
+            <a:srgbClr val="00B4D8"/>
+          </a:solidFill>
+          <a:ln w="12700">
+            <a:solidFill>
+              <a:srgbClr val="00B4D8"/>
+            </a:solidFill>
+            <a:prstDash val="solid"/>
+          </a:ln>
+        </p:spPr>
+      </p:sp>
+      <p:sp>
+        <p:nvSpPr>
+          <p:cNvPr id="5" name="Shape 2"/>
+          <p:cNvSpPr/>
+          <p:nvPr/>
+        </p:nvSpPr>
+        <p:spPr>
+          <a:xfrm>
+            <a:off x="6035040" y="274320"/>
+            <a:ext cx="2651760" cy="457200"/>
+          </a:xfrm>
+          <a:prstGeom prst="rect">
+            <a:avLst/>
+          </a:prstGeom>
+          <a:solidFill>
+            <a:srgbClr val="FF6B35"/>
+          </a:solidFill>
+          <a:ln w="12700">
+            <a:solidFill>
+              <a:srgbClr val="FF6B35"/>
+            </a:solidFill>
+            <a:prstDash val="solid"/>
+          </a:ln>
+        </p:spPr>
+      </p:sp>
+      <p:sp>
+        <p:nvSpPr>
+          <p:cNvPr id="6" name="Text 3"/>
+          <p:cNvSpPr txBox="1"/>
+          <p:nvPr/>
+        </p:nvSpPr>
+        <p:spPr>
+          <a:xfrm>
+            <a:off x="6035040" y="274320"/>
+            <a:ext cx="2651760" cy="457200"/>
+          </a:xfrm>
+          <a:prstGeom prst="rect">
+            <a:avLst/>
+          </a:prstGeom>
+          <a:noFill/>
+          <a:ln/>
+        </p:spPr>
+        <p:txBody>
+          <a:bodyPr wrap="square" lIns="0" tIns="0" rIns="0" bIns="0" rtlCol="0" anchor="ctr"/>
+          <a:lstStyle/>
+          <a:p>
+            <a:pPr algn="ctr" indent="0" marL="0">
+              <a:buNone/>
+            </a:pPr>
+            <a:r>
+              <a:rPr lang="en-US" sz="1200" b="1" dirty="0">
+                <a:solidFill>
+                  <a:srgbClr val="FFFFFF"/>
+                </a:solidFill>
+                <a:latin typeface="Calibri" pitchFamily="34" charset="0"/>
+                <a:ea typeface="Calibri" pitchFamily="34" charset="-122"/>
+                <a:cs typeface="Calibri" pitchFamily="34" charset="-120"/>
+              </a:rPr>
+              <a:t>SWITCH TO COPILOT STUDIO</a:t>
+            </a:r>
+            <a:endParaRPr lang="en-US" sz="1200" dirty="0"/>
+          </a:p>
+        </p:txBody>
+      </p:sp>
+      <p:sp>
+        <p:nvSpPr>
+          <p:cNvPr id="7" name="Shape 4"/>
+          <p:cNvSpPr/>
+          <p:nvPr/>
+        </p:nvSpPr>
+        <p:spPr>
+          <a:xfrm>
+            <a:off x="457200" y="1234440"/>
+            <a:ext cx="365760" cy="365760"/>
+          </a:xfrm>
+          <a:prstGeom prst="ellipse">
+            <a:avLst/>
+          </a:prstGeom>
+          <a:solidFill>
+            <a:srgbClr val="00B4D8"/>
+          </a:solidFill>
+          <a:ln w="12700">
+            <a:solidFill>
+              <a:srgbClr val="00B4D8"/>
+            </a:solidFill>
+            <a:prstDash val="solid"/>
+          </a:ln>
+        </p:spPr>
+      </p:sp>
+      <p:sp>
+        <p:nvSpPr>
+          <p:cNvPr id="8" name="Text 5"/>
+          <p:cNvSpPr txBox="1"/>
+          <p:nvPr/>
+        </p:nvSpPr>
+        <p:spPr>
+          <a:xfrm>
+            <a:off x="457200" y="1234440"/>
+            <a:ext cx="365760" cy="365760"/>
+          </a:xfrm>
+          <a:prstGeom prst="rect">
+            <a:avLst/>
+          </a:prstGeom>
+          <a:noFill/>
+          <a:ln/>
+        </p:spPr>
+        <p:txBody>
+          <a:bodyPr wrap="square" lIns="0" tIns="0" rIns="0" bIns="0" rtlCol="0" anchor="ctr"/>
+          <a:lstStyle/>
+          <a:p>
+            <a:pPr algn="ctr" indent="0" marL="0">
+              <a:buNone/>
+            </a:pPr>
+            <a:r>
+              <a:rPr lang="en-US" sz="1400" b="1" dirty="0">
+                <a:solidFill>
+                  <a:srgbClr val="0A1628"/>
+                </a:solidFill>
+                <a:latin typeface="Calibri" pitchFamily="34" charset="0"/>
+                <a:ea typeface="Calibri" pitchFamily="34" charset="-122"/>
+                <a:cs typeface="Calibri" pitchFamily="34" charset="-120"/>
+              </a:rPr>
+              <a:t>1</a:t>
+            </a:r>
+            <a:endParaRPr lang="en-US" sz="1400" dirty="0"/>
+          </a:p>
+        </p:txBody>
+      </p:sp>
+      <p:sp>
+        <p:nvSpPr>
+          <p:cNvPr id="9" name="Text 6"/>
+          <p:cNvSpPr txBox="1"/>
+          <p:nvPr/>
+        </p:nvSpPr>
+        <p:spPr>
+          <a:xfrm>
+            <a:off x="1005840" y="1188720"/>
+            <a:ext cx="7680960" cy="685800"/>
+          </a:xfrm>
+          <a:prstGeom prst="rect">
+            <a:avLst/>
+          </a:prstGeom>
+          <a:noFill/>
+          <a:ln/>
+        </p:spPr>
+        <p:txBody>
+          <a:bodyPr wrap="square" lIns="0" tIns="0" rIns="0" bIns="0" rtlCol="0" anchor="t"/>
+          <a:lstStyle/>
+          <a:p>
+            <a:pPr indent="0" marL="0">
+              <a:buNone/>
+            </a:pPr>
+            <a:r>
+              <a:rPr lang="en-US" sz="1600" b="1" dirty="0">
+                <a:solidFill>
+                  <a:srgbClr val="E8F4FD"/>
+                </a:solidFill>
+                <a:latin typeface="Calibri" pitchFamily="34" charset="0"/>
+                <a:ea typeface="Calibri" pitchFamily="34" charset="-122"/>
+                <a:cs typeface="Calibri" pitchFamily="34" charset="-120"/>
+              </a:rPr>
+              <a:t>How is each session structured?</a:t>
+            </a:r>
+            <a:endParaRPr lang="en-US" sz="1600" dirty="0"/>
+          </a:p>
+          <a:p>
+            <a:pPr indent="0" marL="0">
+              <a:buNone/>
+            </a:pPr>
+            <a:r>
+              <a:rPr lang="en-US" sz="1300" dirty="0">
+                <a:solidFill>
+                  <a:srgbClr val="90B8D4"/>
+                </a:solidFill>
+                <a:latin typeface="Calibri" pitchFamily="34" charset="0"/>
+                <a:ea typeface="Calibri" pitchFamily="34" charset="-122"/>
+                <a:cs typeface="Calibri" pitchFamily="34" charset="-120"/>
+              </a:rPr>
+              <a:t>Expect: answer from the FAQ, with citation</a:t>
+            </a:r>
+            <a:endParaRPr lang="en-US" sz="1600" dirty="0"/>
+          </a:p>
+        </p:txBody>
+      </p:sp>
+      <p:sp>
+        <p:nvSpPr>
+          <p:cNvPr id="10" name="Shape 7"/>
+          <p:cNvSpPr/>
+          <p:nvPr/>
+        </p:nvSpPr>
+        <p:spPr>
+          <a:xfrm>
+            <a:off x="457200" y="1965960"/>
+            <a:ext cx="365760" cy="365760"/>
+          </a:xfrm>
+          <a:prstGeom prst="ellipse">
+            <a:avLst/>
+          </a:prstGeom>
+          <a:solidFill>
+            <a:srgbClr val="00B4D8"/>
+          </a:solidFill>
+          <a:ln w="12700">
+            <a:solidFill>
+              <a:srgbClr val="00B4D8"/>
+            </a:solidFill>
+            <a:prstDash val="solid"/>
+          </a:ln>
+        </p:spPr>
+      </p:sp>
+      <p:sp>
+        <p:nvSpPr>
+          <p:cNvPr id="11" name="Text 8"/>
+          <p:cNvSpPr txBox="1"/>
+          <p:nvPr/>
+        </p:nvSpPr>
+        <p:spPr>
+          <a:xfrm>
+            <a:off x="457200" y="1965960"/>
+            <a:ext cx="365760" cy="365760"/>
+          </a:xfrm>
+          <a:prstGeom prst="rect">
+            <a:avLst/>
+          </a:prstGeom>
+          <a:noFill/>
+          <a:ln/>
+        </p:spPr>
+        <p:txBody>
+          <a:bodyPr wrap="square" lIns="0" tIns="0" rIns="0" bIns="0" rtlCol="0" anchor="ctr"/>
+          <a:lstStyle/>
+          <a:p>
+            <a:pPr algn="ctr" indent="0" marL="0">
+              <a:buNone/>
+            </a:pPr>
+            <a:r>
+              <a:rPr lang="en-US" sz="1400" b="1" dirty="0">
+                <a:solidFill>
+                  <a:srgbClr val="0A1628"/>
+                </a:solidFill>
+                <a:latin typeface="Calibri" pitchFamily="34" charset="0"/>
+                <a:ea typeface="Calibri" pitchFamily="34" charset="-122"/>
+                <a:cs typeface="Calibri" pitchFamily="34" charset="-120"/>
+              </a:rPr>
+              <a:t>2</a:t>
+            </a:r>
+            <a:endParaRPr lang="en-US" sz="1400" dirty="0"/>
+          </a:p>
+        </p:txBody>
+      </p:sp>
+      <p:sp>
+        <p:nvSpPr>
+          <p:cNvPr id="12" name="Text 9"/>
+          <p:cNvSpPr txBox="1"/>
+          <p:nvPr/>
+        </p:nvSpPr>
+        <p:spPr>
+          <a:xfrm>
+            <a:off x="1005840" y="1920240"/>
+            <a:ext cx="7680960" cy="685800"/>
+          </a:xfrm>
+          <a:prstGeom prst="rect">
+            <a:avLst/>
+          </a:prstGeom>
+          <a:noFill/>
+          <a:ln/>
+        </p:spPr>
+        <p:txBody>
+          <a:bodyPr wrap="square" lIns="0" tIns="0" rIns="0" bIns="0" rtlCol="0" anchor="t"/>
+          <a:lstStyle/>
+          <a:p>
+            <a:pPr indent="0" marL="0">
+              <a:buNone/>
+            </a:pPr>
+            <a:r>
+              <a:rPr lang="en-US" sz="1600" b="1" dirty="0">
+                <a:solidFill>
+                  <a:srgbClr val="E8F4FD"/>
+                </a:solidFill>
+                <a:latin typeface="Calibri" pitchFamily="34" charset="0"/>
+                <a:ea typeface="Calibri" pitchFamily="34" charset="-122"/>
+                <a:cs typeface="Calibri" pitchFamily="34" charset="-120"/>
+              </a:rPr>
+              <a:t>How do I add a public website as a knowledge source in Copilot Studio?</a:t>
+            </a:r>
+            <a:endParaRPr lang="en-US" sz="1600" dirty="0"/>
+          </a:p>
+          <a:p>
+            <a:pPr indent="0" marL="0">
+              <a:buNone/>
+            </a:pPr>
+            <a:r>
+              <a:rPr lang="en-US" sz="1300" dirty="0">
+                <a:solidFill>
+                  <a:srgbClr val="90B8D4"/>
+                </a:solidFill>
+                <a:latin typeface="Calibri" pitchFamily="34" charset="0"/>
+                <a:ea typeface="Calibri" pitchFamily="34" charset="-122"/>
+                <a:cs typeface="Calibri" pitchFamily="34" charset="-120"/>
+              </a:rPr>
+              <a:t>Expect: answer from Microsoft docs, with citation</a:t>
+            </a:r>
+            <a:endParaRPr lang="en-US" sz="1600" dirty="0"/>
+          </a:p>
+        </p:txBody>
+      </p:sp>
+      <p:sp>
+        <p:nvSpPr>
+          <p:cNvPr id="13" name="Shape 10"/>
+          <p:cNvSpPr/>
+          <p:nvPr/>
+        </p:nvSpPr>
+        <p:spPr>
+          <a:xfrm>
+            <a:off x="457200" y="2697480"/>
+            <a:ext cx="365760" cy="365760"/>
+          </a:xfrm>
+          <a:prstGeom prst="ellipse">
+            <a:avLst/>
+          </a:prstGeom>
+          <a:solidFill>
+            <a:srgbClr val="00B4D8"/>
+          </a:solidFill>
+          <a:ln w="12700">
+            <a:solidFill>
+              <a:srgbClr val="00B4D8"/>
+            </a:solidFill>
+            <a:prstDash val="solid"/>
+          </a:ln>
+        </p:spPr>
+      </p:sp>
+      <p:sp>
+        <p:nvSpPr>
+          <p:cNvPr id="14" name="Text 11"/>
+          <p:cNvSpPr txBox="1"/>
+          <p:nvPr/>
+        </p:nvSpPr>
+        <p:spPr>
+          <a:xfrm>
+            <a:off x="457200" y="2697480"/>
+            <a:ext cx="365760" cy="365760"/>
+          </a:xfrm>
+          <a:prstGeom prst="rect">
+            <a:avLst/>
+          </a:prstGeom>
+          <a:noFill/>
+          <a:ln/>
+        </p:spPr>
+        <p:txBody>
+          <a:bodyPr wrap="square" lIns="0" tIns="0" rIns="0" bIns="0" rtlCol="0" anchor="ctr"/>
+          <a:lstStyle/>
+          <a:p>
+            <a:pPr algn="ctr" indent="0" marL="0">
+              <a:buNone/>
+            </a:pPr>
+            <a:r>
+              <a:rPr lang="en-US" sz="1400" b="1" dirty="0">
+                <a:solidFill>
+                  <a:srgbClr val="0A1628"/>
+                </a:solidFill>
+                <a:latin typeface="Calibri" pitchFamily="34" charset="0"/>
+                <a:ea typeface="Calibri" pitchFamily="34" charset="-122"/>
+                <a:cs typeface="Calibri" pitchFamily="34" charset="-120"/>
+              </a:rPr>
+              <a:t>3</a:t>
+            </a:r>
+            <a:endParaRPr lang="en-US" sz="1400" dirty="0"/>
+          </a:p>
+        </p:txBody>
+      </p:sp>
+      <p:sp>
+        <p:nvSpPr>
+          <p:cNvPr id="15" name="Text 12"/>
+          <p:cNvSpPr txBox="1"/>
+          <p:nvPr/>
+        </p:nvSpPr>
+        <p:spPr>
+          <a:xfrm>
+            <a:off x="1005840" y="2651760"/>
+            <a:ext cx="7680960" cy="685800"/>
+          </a:xfrm>
+          <a:prstGeom prst="rect">
+            <a:avLst/>
+          </a:prstGeom>
+          <a:noFill/>
+          <a:ln/>
+        </p:spPr>
+        <p:txBody>
+          <a:bodyPr wrap="square" lIns="0" tIns="0" rIns="0" bIns="0" rtlCol="0" anchor="t"/>
+          <a:lstStyle/>
+          <a:p>
+            <a:pPr indent="0" marL="0">
+              <a:buNone/>
+            </a:pPr>
+            <a:r>
+              <a:rPr lang="en-US" sz="1600" b="1" dirty="0">
+                <a:solidFill>
+                  <a:srgbClr val="E8F4FD"/>
+                </a:solidFill>
+                <a:latin typeface="Calibri" pitchFamily="34" charset="0"/>
+                <a:ea typeface="Calibri" pitchFamily="34" charset="-122"/>
+                <a:cs typeface="Calibri" pitchFamily="34" charset="-120"/>
+              </a:rPr>
+              <a:t>How much does the programme cost?</a:t>
+            </a:r>
+            <a:endParaRPr lang="en-US" sz="1600" dirty="0"/>
+          </a:p>
+          <a:p>
+            <a:pPr indent="0" marL="0">
+              <a:buNone/>
+            </a:pPr>
+            <a:r>
+              <a:rPr lang="en-US" sz="1300" dirty="0">
+                <a:solidFill>
+                  <a:srgbClr val="90B8D4"/>
+                </a:solidFill>
+                <a:latin typeface="Calibri" pitchFamily="34" charset="0"/>
+                <a:ea typeface="Calibri" pitchFamily="34" charset="-122"/>
+                <a:cs typeface="Calibri" pitchFamily="34" charset="-120"/>
+              </a:rPr>
+              <a:t>Expect: declines, not in sources</a:t>
+            </a:r>
+            <a:endParaRPr lang="en-US" sz="1600" dirty="0"/>
+          </a:p>
+        </p:txBody>
+      </p:sp>
+      <p:sp>
+        <p:nvSpPr>
+          <p:cNvPr id="16" name="Shape 13"/>
+          <p:cNvSpPr/>
+          <p:nvPr/>
+        </p:nvSpPr>
+        <p:spPr>
+          <a:xfrm>
+            <a:off x="457200" y="3429000"/>
+            <a:ext cx="365760" cy="365760"/>
+          </a:xfrm>
+          <a:prstGeom prst="ellipse">
+            <a:avLst/>
+          </a:prstGeom>
+          <a:solidFill>
+            <a:srgbClr val="00B4D8"/>
+          </a:solidFill>
+          <a:ln w="12700">
+            <a:solidFill>
+              <a:srgbClr val="00B4D8"/>
+            </a:solidFill>
+            <a:prstDash val="solid"/>
+          </a:ln>
+        </p:spPr>
+      </p:sp>
+      <p:sp>
+        <p:nvSpPr>
+          <p:cNvPr id="17" name="Text 14"/>
+          <p:cNvSpPr txBox="1"/>
+          <p:nvPr/>
+        </p:nvSpPr>
+        <p:spPr>
+          <a:xfrm>
+            <a:off x="457200" y="3429000"/>
+            <a:ext cx="365760" cy="365760"/>
+          </a:xfrm>
+          <a:prstGeom prst="rect">
+            <a:avLst/>
+          </a:prstGeom>
+          <a:noFill/>
+          <a:ln/>
+        </p:spPr>
+        <p:txBody>
+          <a:bodyPr wrap="square" lIns="0" tIns="0" rIns="0" bIns="0" rtlCol="0" anchor="ctr"/>
+          <a:lstStyle/>
+          <a:p>
+            <a:pPr algn="ctr" indent="0" marL="0">
+              <a:buNone/>
+            </a:pPr>
+            <a:r>
+              <a:rPr lang="en-US" sz="1400" b="1" dirty="0">
+                <a:solidFill>
+                  <a:srgbClr val="0A1628"/>
+                </a:solidFill>
+                <a:latin typeface="Calibri" pitchFamily="34" charset="0"/>
+                <a:ea typeface="Calibri" pitchFamily="34" charset="-122"/>
+                <a:cs typeface="Calibri" pitchFamily="34" charset="-120"/>
+              </a:rPr>
+              <a:t>4</a:t>
+            </a:r>
+            <a:endParaRPr lang="en-US" sz="1400" dirty="0"/>
+          </a:p>
+        </p:txBody>
+      </p:sp>
+      <p:sp>
+        <p:nvSpPr>
+          <p:cNvPr id="18" name="Text 15"/>
+          <p:cNvSpPr txBox="1"/>
+          <p:nvPr/>
+        </p:nvSpPr>
+        <p:spPr>
+          <a:xfrm>
+            <a:off x="1005840" y="3383280"/>
+            <a:ext cx="7680960" cy="685800"/>
+          </a:xfrm>
+          <a:prstGeom prst="rect">
+            <a:avLst/>
+          </a:prstGeom>
+          <a:noFill/>
+          <a:ln/>
+        </p:spPr>
+        <p:txBody>
+          <a:bodyPr wrap="square" lIns="0" tIns="0" rIns="0" bIns="0" rtlCol="0" anchor="t"/>
+          <a:lstStyle/>
+          <a:p>
+            <a:pPr indent="0" marL="0">
+              <a:buNone/>
+            </a:pPr>
+            <a:r>
+              <a:rPr lang="en-US" sz="1600" b="1" dirty="0">
+                <a:solidFill>
+                  <a:srgbClr val="E8F4FD"/>
+                </a:solidFill>
+                <a:latin typeface="Calibri" pitchFamily="34" charset="0"/>
+                <a:ea typeface="Calibri" pitchFamily="34" charset="-122"/>
+                <a:cs typeface="Calibri" pitchFamily="34" charset="-120"/>
+              </a:rPr>
+              <a:t>Which political party should I support?</a:t>
+            </a:r>
+            <a:endParaRPr lang="en-US" sz="1600" dirty="0"/>
+          </a:p>
+          <a:p>
+            <a:pPr indent="0" marL="0">
+              <a:buNone/>
+            </a:pPr>
+            <a:r>
+              <a:rPr lang="en-US" sz="1300" dirty="0">
+                <a:solidFill>
+                  <a:srgbClr val="90B8D4"/>
+                </a:solidFill>
+                <a:latin typeface="Calibri" pitchFamily="34" charset="0"/>
+                <a:ea typeface="Calibri" pitchFamily="34" charset="-122"/>
+                <a:cs typeface="Calibri" pitchFamily="34" charset="-120"/>
+              </a:rPr>
+              <a:t>Expect: declines, out of scope</a:t>
+            </a:r>
+            <a:endParaRPr lang="en-US" sz="1600" dirty="0"/>
+          </a:p>
+        </p:txBody>
+      </p:sp>
+      <p:sp>
+        <p:nvSpPr>
+          <p:cNvPr id="19" name="Text 16"/>
+          <p:cNvSpPr txBox="1"/>
+          <p:nvPr/>
+        </p:nvSpPr>
+        <p:spPr>
+          <a:xfrm>
+            <a:off x="457200" y="4572000"/>
+            <a:ext cx="8229600" cy="274320"/>
+          </a:xfrm>
+          <a:prstGeom prst="rect">
+            <a:avLst/>
+          </a:prstGeom>
+          <a:noFill/>
+          <a:ln/>
+        </p:spPr>
+        <p:txBody>
+          <a:bodyPr wrap="square" lIns="0" tIns="0" rIns="0" bIns="0" rtlCol="0" anchor="ctr"/>
+          <a:lstStyle/>
+          <a:p>
+            <a:pPr indent="0" marL="0">
+              <a:buNone/>
+            </a:pPr>
+            <a:r>
+              <a:rPr lang="en-US" sz="1200" i="1" dirty="0">
+                <a:solidFill>
+                  <a:srgbClr val="90B8D4"/>
+                </a:solidFill>
+                <a:latin typeface="Calibri" pitchFamily="34" charset="0"/>
+                <a:ea typeface="Calibri" pitchFamily="34" charset="-122"/>
+                <a:cs typeface="Calibri" pitchFamily="34" charset="-120"/>
+              </a:rPr>
+              <a:t>Then return to the slides</a:t>
+            </a:r>
+            <a:endParaRPr lang="en-US" sz="1200" dirty="0"/>
+          </a:p>
+        </p:txBody>
+      </p:sp>
+    </p:spTree>
+  </p:cSld>
+  <p:clrMapOvr>
+    <a:masterClrMapping/>
+  </p:clrMapOvr>
+</p:sld>
+</file>
+
+<file path=ppt/slides/slide11.xml><?xml version="1.0" encoding="utf-8"?>
+<p:sld xmlns:a="http://schemas.openxmlformats.org/drawingml/2006/main" xmlns:r="http://schemas.openxmlformats.org/officeDocument/2006/relationships" xmlns:p="http://schemas.openxmlformats.org/presentationml/2006/main">
+  <p:cSld name="Slide 11">
+    <p:bg>
+      <p:bgPr>
+        <a:solidFill>
+          <a:srgbClr val="0A1628"/>
+        </a:solidFill>
+      </p:bgPr>
+    </p:bg>
+    <p:spTree>
+      <p:nvGrpSpPr>
+        <p:cNvPr id="1" name=""/>
+        <p:cNvGrpSpPr/>
+        <p:nvPr/>
+      </p:nvGrpSpPr>
+      <p:grpSpPr>
+        <a:xfrm>
+          <a:off x="0" y="0"/>
+          <a:ext cx="0" cy="0"/>
+          <a:chOff x="0" y="0"/>
+          <a:chExt cx="0" cy="0"/>
+        </a:xfrm>
+      </p:grpSpPr>
+      <p:sp>
+        <p:nvSpPr>
+          <p:cNvPr id="2" name="Text 0"/>
+          <p:cNvSpPr txBox="1"/>
+          <p:nvPr/>
+        </p:nvSpPr>
+        <p:spPr>
+          <a:xfrm>
+            <a:off x="457200" y="274320"/>
+            <a:ext cx="8229600" cy="548640"/>
+          </a:xfrm>
+          <a:prstGeom prst="rect">
+            <a:avLst/>
+          </a:prstGeom>
+          <a:noFill/>
+          <a:ln/>
+        </p:spPr>
+        <p:txBody>
+          <a:bodyPr wrap="square" lIns="0" tIns="0" rIns="0" bIns="0" rtlCol="0" anchor="ctr"/>
+          <a:lstStyle/>
+          <a:p>
+            <a:pPr indent="0" marL="0">
+              <a:buNone/>
+            </a:pPr>
+            <a:r>
+              <a:rPr lang="en-US" sz="2800" b="1" dirty="0">
+                <a:solidFill>
+                  <a:srgbClr val="FFFFFF"/>
+                </a:solidFill>
+                <a:latin typeface="Calibri" pitchFamily="34" charset="0"/>
+                <a:ea typeface="Calibri" pitchFamily="34" charset="-122"/>
+                <a:cs typeface="Calibri" pitchFamily="34" charset="-120"/>
+              </a:rPr>
+              <a:t>What can go wrong, and takeaways</a:t>
+            </a:r>
+            <a:endParaRPr lang="en-US" sz="2800" dirty="0"/>
+          </a:p>
+        </p:txBody>
+      </p:sp>
+      <p:sp>
+        <p:nvSpPr>
+          <p:cNvPr id="3" name="Shape 1"/>
+          <p:cNvSpPr/>
+          <p:nvPr/>
+        </p:nvSpPr>
+        <p:spPr>
+          <a:xfrm>
+            <a:off x="457200" y="868680"/>
+            <a:ext cx="1097280" cy="54864"/>
+          </a:xfrm>
+          <a:prstGeom prst="rect">
+            <a:avLst/>
+          </a:prstGeom>
+          <a:solidFill>
+            <a:srgbClr val="00B4D8"/>
+          </a:solidFill>
+          <a:ln w="12700">
+            <a:solidFill>
+              <a:srgbClr val="00B4D8"/>
+            </a:solidFill>
+            <a:prstDash val="solid"/>
+          </a:ln>
+        </p:spPr>
+      </p:sp>
+      <p:sp>
+        <p:nvSpPr>
+          <p:cNvPr id="5" name="Shape 2"/>
+          <p:cNvSpPr/>
+          <p:nvPr/>
+        </p:nvSpPr>
+        <p:spPr>
+          <a:xfrm>
+            <a:off x="457200" y="1188720"/>
+            <a:ext cx="1828800" cy="2103120"/>
+          </a:xfrm>
+          <a:prstGeom prst="rect">
+            <a:avLst/>
+          </a:prstGeom>
+          <a:solidFill>
+            <a:srgbClr val="102235"/>
+          </a:solidFill>
+          <a:ln w="19050">
+            <a:solidFill>
+              <a:srgbClr val="FF6B35"/>
+            </a:solidFill>
+            <a:prstDash val="solid"/>
+          </a:ln>
+        </p:spPr>
+      </p:sp>
+      <p:sp>
+        <p:nvSpPr>
+          <p:cNvPr id="6" name="Text 3"/>
+          <p:cNvSpPr txBox="1"/>
+          <p:nvPr/>
+        </p:nvSpPr>
+        <p:spPr>
+          <a:xfrm>
+            <a:off x="640080" y="1325880"/>
+            <a:ext cx="1463040" cy="457200"/>
+          </a:xfrm>
+          <a:prstGeom prst="rect">
+            <a:avLst/>
+          </a:prstGeom>
+          <a:noFill/>
+          <a:ln/>
+        </p:spPr>
+        <p:txBody>
+          <a:bodyPr wrap="square" lIns="0" tIns="0" rIns="0" bIns="0" rtlCol="0" anchor="t"/>
+          <a:lstStyle/>
+          <a:p>
+            <a:pPr indent="0" marL="0">
+              <a:buNone/>
+            </a:pPr>
+            <a:r>
+              <a:rPr lang="en-US" sz="2000" b="1" dirty="0">
+                <a:solidFill>
+                  <a:srgbClr val="FF6B35"/>
+                </a:solidFill>
+                <a:latin typeface="Calibri" pitchFamily="34" charset="0"/>
+                <a:ea typeface="Calibri" pitchFamily="34" charset="-122"/>
+                <a:cs typeface="Calibri" pitchFamily="34" charset="-120"/>
+              </a:rPr>
+              <a:t>Poor retrieval</a:t>
+            </a:r>
+            <a:endParaRPr lang="en-US" sz="2000" dirty="0"/>
+          </a:p>
+        </p:txBody>
+      </p:sp>
+      <p:sp>
+        <p:nvSpPr>
+          <p:cNvPr id="7" name="Text 4"/>
+          <p:cNvSpPr txBox="1"/>
+          <p:nvPr/>
+        </p:nvSpPr>
+        <p:spPr>
+          <a:xfrm>
+            <a:off x="640080" y="1874520"/>
+            <a:ext cx="1463040" cy="1234440"/>
+          </a:xfrm>
+          <a:prstGeom prst="rect">
+            <a:avLst/>
+          </a:prstGeom>
+          <a:noFill/>
+          <a:ln/>
+        </p:spPr>
+        <p:txBody>
+          <a:bodyPr wrap="square" lIns="0" tIns="0" rIns="0" bIns="0" rtlCol="0" anchor="t"/>
+          <a:lstStyle/>
+          <a:p>
+            <a:pPr indent="0" marL="0">
+              <a:buNone/>
+            </a:pPr>
+            <a:r>
+              <a:rPr lang="en-US" sz="1600" dirty="0">
+                <a:solidFill>
+                  <a:srgbClr val="E8F4FD"/>
+                </a:solidFill>
+                <a:latin typeface="Calibri" pitchFamily="34" charset="0"/>
+                <a:ea typeface="Calibri" pitchFamily="34" charset="-122"/>
+                <a:cs typeface="Calibri" pitchFamily="34" charset="-120"/>
+              </a:rPr>
+              <a:t>Wrong passage found</a:t>
+            </a:r>
+            <a:endParaRPr lang="en-US" sz="1600" dirty="0"/>
+          </a:p>
+        </p:txBody>
+      </p:sp>
+      <p:sp>
+        <p:nvSpPr>
+          <p:cNvPr id="8" name="Shape 5"/>
+          <p:cNvSpPr/>
+          <p:nvPr/>
+        </p:nvSpPr>
+        <p:spPr>
+          <a:xfrm>
+            <a:off x="2423160" y="1188720"/>
+            <a:ext cx="1828800" cy="2103120"/>
+          </a:xfrm>
+          <a:prstGeom prst="rect">
+            <a:avLst/>
+          </a:prstGeom>
+          <a:solidFill>
+            <a:srgbClr val="102235"/>
+          </a:solidFill>
+          <a:ln w="19050">
+            <a:solidFill>
+              <a:srgbClr val="FF6B35"/>
+            </a:solidFill>
+            <a:prstDash val="solid"/>
+          </a:ln>
+        </p:spPr>
+      </p:sp>
+      <p:sp>
+        <p:nvSpPr>
+          <p:cNvPr id="9" name="Text 6"/>
+          <p:cNvSpPr txBox="1"/>
+          <p:nvPr/>
+        </p:nvSpPr>
+        <p:spPr>
+          <a:xfrm>
+            <a:off x="2606040" y="1325880"/>
+            <a:ext cx="1463040" cy="457200"/>
+          </a:xfrm>
+          <a:prstGeom prst="rect">
+            <a:avLst/>
+          </a:prstGeom>
+          <a:noFill/>
+          <a:ln/>
+        </p:spPr>
+        <p:txBody>
+          <a:bodyPr wrap="square" lIns="0" tIns="0" rIns="0" bIns="0" rtlCol="0" anchor="t"/>
+          <a:lstStyle/>
+          <a:p>
+            <a:pPr indent="0" marL="0">
+              <a:buNone/>
+            </a:pPr>
+            <a:r>
+              <a:rPr lang="en-US" sz="2000" b="1" dirty="0">
+                <a:solidFill>
+                  <a:srgbClr val="FF6B35"/>
+                </a:solidFill>
+                <a:latin typeface="Calibri" pitchFamily="34" charset="0"/>
+                <a:ea typeface="Calibri" pitchFamily="34" charset="-122"/>
+                <a:cs typeface="Calibri" pitchFamily="34" charset="-120"/>
+              </a:rPr>
+              <a:t>Stale sources</a:t>
+            </a:r>
+            <a:endParaRPr lang="en-US" sz="2000" dirty="0"/>
+          </a:p>
+        </p:txBody>
+      </p:sp>
+      <p:sp>
+        <p:nvSpPr>
+          <p:cNvPr id="10" name="Text 7"/>
+          <p:cNvSpPr txBox="1"/>
+          <p:nvPr/>
+        </p:nvSpPr>
+        <p:spPr>
+          <a:xfrm>
+            <a:off x="2606040" y="1874520"/>
+            <a:ext cx="1463040" cy="1234440"/>
+          </a:xfrm>
+          <a:prstGeom prst="rect">
+            <a:avLst/>
+          </a:prstGeom>
+          <a:noFill/>
+          <a:ln/>
+        </p:spPr>
+        <p:txBody>
+          <a:bodyPr wrap="square" lIns="0" tIns="0" rIns="0" bIns="0" rtlCol="0" anchor="t"/>
+          <a:lstStyle/>
+          <a:p>
+            <a:pPr indent="0" marL="0">
+              <a:buNone/>
+            </a:pPr>
+            <a:r>
+              <a:rPr lang="en-US" sz="1600" dirty="0">
+                <a:solidFill>
+                  <a:srgbClr val="E8F4FD"/>
+                </a:solidFill>
+                <a:latin typeface="Calibri" pitchFamily="34" charset="0"/>
+                <a:ea typeface="Calibri" pitchFamily="34" charset="-122"/>
+                <a:cs typeface="Calibri" pitchFamily="34" charset="-120"/>
+              </a:rPr>
+              <a:t>Someone must own updates</a:t>
+            </a:r>
+            <a:endParaRPr lang="en-US" sz="1600" dirty="0"/>
+          </a:p>
+        </p:txBody>
+      </p:sp>
+      <p:sp>
+        <p:nvSpPr>
+          <p:cNvPr id="11" name="Shape 8"/>
+          <p:cNvSpPr/>
+          <p:nvPr/>
+        </p:nvSpPr>
+        <p:spPr>
+          <a:xfrm>
+            <a:off x="4389120" y="1188720"/>
+            <a:ext cx="1828800" cy="2103120"/>
+          </a:xfrm>
+          <a:prstGeom prst="rect">
+            <a:avLst/>
+          </a:prstGeom>
+          <a:solidFill>
+            <a:srgbClr val="102235"/>
+          </a:solidFill>
+          <a:ln w="19050">
+            <a:solidFill>
+              <a:srgbClr val="FF6B35"/>
+            </a:solidFill>
+            <a:prstDash val="solid"/>
+          </a:ln>
+        </p:spPr>
+      </p:sp>
+      <p:sp>
+        <p:nvSpPr>
+          <p:cNvPr id="12" name="Text 9"/>
+          <p:cNvSpPr txBox="1"/>
+          <p:nvPr/>
+        </p:nvSpPr>
+        <p:spPr>
+          <a:xfrm>
+            <a:off x="4572000" y="1325880"/>
+            <a:ext cx="1463040" cy="457200"/>
+          </a:xfrm>
+          <a:prstGeom prst="rect">
+            <a:avLst/>
+          </a:prstGeom>
+          <a:noFill/>
+          <a:ln/>
+        </p:spPr>
+        <p:txBody>
+          <a:bodyPr wrap="square" lIns="0" tIns="0" rIns="0" bIns="0" rtlCol="0" anchor="t"/>
+          <a:lstStyle/>
+          <a:p>
+            <a:pPr indent="0" marL="0">
+              <a:buNone/>
+            </a:pPr>
+            <a:r>
+              <a:rPr lang="en-US" sz="2000" b="1" dirty="0">
+                <a:solidFill>
+                  <a:srgbClr val="FF6B35"/>
+                </a:solidFill>
+                <a:latin typeface="Calibri" pitchFamily="34" charset="0"/>
+                <a:ea typeface="Calibri" pitchFamily="34" charset="-122"/>
+                <a:cs typeface="Calibri" pitchFamily="34" charset="-120"/>
+              </a:rPr>
+              <a:t>Conflicts</a:t>
+            </a:r>
+            <a:endParaRPr lang="en-US" sz="2000" dirty="0"/>
+          </a:p>
+        </p:txBody>
+      </p:sp>
+      <p:sp>
+        <p:nvSpPr>
+          <p:cNvPr id="13" name="Text 10"/>
+          <p:cNvSpPr txBox="1"/>
+          <p:nvPr/>
+        </p:nvSpPr>
+        <p:spPr>
+          <a:xfrm>
+            <a:off x="4572000" y="1874520"/>
+            <a:ext cx="1463040" cy="1234440"/>
+          </a:xfrm>
+          <a:prstGeom prst="rect">
+            <a:avLst/>
+          </a:prstGeom>
+          <a:noFill/>
+          <a:ln/>
+        </p:spPr>
+        <p:txBody>
+          <a:bodyPr wrap="square" lIns="0" tIns="0" rIns="0" bIns="0" rtlCol="0" anchor="t"/>
+          <a:lstStyle/>
+          <a:p>
+            <a:pPr indent="0" marL="0">
+              <a:buNone/>
+            </a:pPr>
+            <a:r>
+              <a:rPr lang="en-US" sz="1600" dirty="0">
+                <a:solidFill>
+                  <a:srgbClr val="E8F4FD"/>
+                </a:solidFill>
+                <a:latin typeface="Calibri" pitchFamily="34" charset="0"/>
+                <a:ea typeface="Calibri" pitchFamily="34" charset="-122"/>
+                <a:cs typeface="Calibri" pitchFamily="34" charset="-120"/>
+              </a:rPr>
+              <a:t>Decide which source wins</a:t>
+            </a:r>
+            <a:endParaRPr lang="en-US" sz="1600" dirty="0"/>
+          </a:p>
+        </p:txBody>
+      </p:sp>
+      <p:sp>
+        <p:nvSpPr>
+          <p:cNvPr id="14" name="Shape 11"/>
+          <p:cNvSpPr/>
+          <p:nvPr/>
+        </p:nvSpPr>
+        <p:spPr>
+          <a:xfrm>
+            <a:off x="6355080" y="1188720"/>
+            <a:ext cx="2331720" cy="2103120"/>
+          </a:xfrm>
+          <a:prstGeom prst="rect">
+            <a:avLst/>
+          </a:prstGeom>
+          <a:solidFill>
+            <a:srgbClr val="102235"/>
+          </a:solidFill>
+          <a:ln w="19050">
+            <a:solidFill>
+              <a:srgbClr val="FF6B35"/>
+            </a:solidFill>
+            <a:prstDash val="solid"/>
+          </a:ln>
+        </p:spPr>
+      </p:sp>
+      <p:sp>
+        <p:nvSpPr>
+          <p:cNvPr id="15" name="Text 12"/>
+          <p:cNvSpPr txBox="1"/>
+          <p:nvPr/>
+        </p:nvSpPr>
+        <p:spPr>
+          <a:xfrm>
+            <a:off x="6537960" y="1325880"/>
+            <a:ext cx="1965960" cy="457200"/>
+          </a:xfrm>
+          <a:prstGeom prst="rect">
+            <a:avLst/>
+          </a:prstGeom>
+          <a:noFill/>
+          <a:ln/>
+        </p:spPr>
+        <p:txBody>
+          <a:bodyPr wrap="square" lIns="0" tIns="0" rIns="0" bIns="0" rtlCol="0" anchor="t"/>
+          <a:lstStyle/>
+          <a:p>
+            <a:pPr indent="0" marL="0">
+              <a:buNone/>
+            </a:pPr>
+            <a:r>
+              <a:rPr lang="en-US" sz="2000" b="1" dirty="0">
+                <a:solidFill>
+                  <a:srgbClr val="FF6B35"/>
+                </a:solidFill>
+                <a:latin typeface="Calibri" pitchFamily="34" charset="0"/>
+                <a:ea typeface="Calibri" pitchFamily="34" charset="-122"/>
+                <a:cs typeface="Calibri" pitchFamily="34" charset="-120"/>
+              </a:rPr>
+              <a:t>Setting clash</a:t>
+            </a:r>
+            <a:endParaRPr lang="en-US" sz="2000" dirty="0"/>
+          </a:p>
+        </p:txBody>
+      </p:sp>
+      <p:sp>
+        <p:nvSpPr>
+          <p:cNvPr id="16" name="Text 13"/>
+          <p:cNvSpPr txBox="1"/>
+          <p:nvPr/>
+        </p:nvSpPr>
+        <p:spPr>
+          <a:xfrm>
+            <a:off x="6537960" y="1874520"/>
+            <a:ext cx="1965960" cy="1234440"/>
+          </a:xfrm>
+          <a:prstGeom prst="rect">
+            <a:avLst/>
+          </a:prstGeom>
+          <a:noFill/>
+          <a:ln/>
+        </p:spPr>
+        <p:txBody>
+          <a:bodyPr wrap="square" lIns="0" tIns="0" rIns="0" bIns="0" rtlCol="0" anchor="t"/>
+          <a:lstStyle/>
+          <a:p>
+            <a:pPr indent="0" marL="0">
+              <a:buNone/>
+            </a:pPr>
+            <a:r>
+              <a:rPr lang="en-US" sz="1600" dirty="0">
+                <a:solidFill>
+                  <a:srgbClr val="E8F4FD"/>
+                </a:solidFill>
+                <a:latin typeface="Calibri" pitchFamily="34" charset="0"/>
+                <a:ea typeface="Calibri" pitchFamily="34" charset="-122"/>
+                <a:cs typeface="Calibri" pitchFamily="34" charset="-120"/>
+              </a:rPr>
+              <a:t>Instructions vs web search</a:t>
+            </a:r>
+            <a:endParaRPr lang="en-US" sz="1600" dirty="0"/>
+          </a:p>
+        </p:txBody>
+      </p:sp>
+      <p:sp>
+        <p:nvSpPr>
+          <p:cNvPr id="17" name="Shape 14"/>
+          <p:cNvSpPr/>
+          <p:nvPr/>
+        </p:nvSpPr>
+        <p:spPr>
+          <a:xfrm>
+            <a:off x="457200" y="3566160"/>
+            <a:ext cx="8229600" cy="1005840"/>
+          </a:xfrm>
+          <a:prstGeom prst="rect">
+            <a:avLst/>
+          </a:prstGeom>
+          <a:solidFill>
+            <a:srgbClr val="0D2137"/>
+          </a:solidFill>
+          <a:ln w="19050">
+            <a:solidFill>
+              <a:srgbClr val="00B4D8"/>
+            </a:solidFill>
+            <a:prstDash val="solid"/>
+          </a:ln>
+        </p:spPr>
+      </p:sp>
+      <p:sp>
+        <p:nvSpPr>
+          <p:cNvPr id="18" name="Text 15"/>
+          <p:cNvSpPr txBox="1"/>
+          <p:nvPr/>
+        </p:nvSpPr>
+        <p:spPr>
+          <a:xfrm>
+            <a:off x="640080" y="3749040"/>
+            <a:ext cx="7863840" cy="640080"/>
+          </a:xfrm>
+          <a:prstGeom prst="rect">
+            <a:avLst/>
+          </a:prstGeom>
+          <a:noFill/>
+          <a:ln/>
+        </p:spPr>
+        <p:txBody>
+          <a:bodyPr wrap="square" lIns="0" tIns="0" rIns="0" bIns="0" rtlCol="0" anchor="ctr"/>
+          <a:lstStyle/>
+          <a:p>
+            <a:pPr algn="ctr" indent="0" marL="0">
+              <a:buNone/>
+            </a:pPr>
+            <a:r>
+              <a:rPr lang="en-US" sz="1600" b="1" dirty="0">
+                <a:solidFill>
+                  <a:srgbClr val="00B4D8"/>
+                </a:solidFill>
+                <a:latin typeface="Calibri" pitchFamily="34" charset="0"/>
+                <a:ea typeface="Calibri" pitchFamily="34" charset="-122"/>
+                <a:cs typeface="Calibri" pitchFamily="34" charset="-120"/>
+              </a:rPr>
+              <a:t>Retrieve, augment, generate  •  Good sources plus clear instructions  •  Test refusals</a:t>
+            </a:r>
+            <a:endParaRPr lang="en-US" sz="1600" dirty="0"/>
+          </a:p>
+        </p:txBody>
+      </p:sp>
+    </p:spTree>
+  </p:cSld>
+  <p:clrMapOvr>
+    <a:masterClrMapping/>
+  </p:clrMapOvr>
+</p:sld>
+</file>
+
 <file path=ppt/slides/slide2.xml><?xml version="1.0" encoding="utf-8"?>
 <p:sld xmlns:a="http://schemas.openxmlformats.org/drawingml/2006/main" xmlns:r="http://schemas.openxmlformats.org/officeDocument/2006/relationships" xmlns:p="http://schemas.openxmlformats.org/presentationml/2006/main">
   <p:cSld name="Slide 2">
@@ -3701,7 +5219,7 @@
                 <a:ea typeface="Calibri" pitchFamily="34" charset="-122"/>
                 <a:cs typeface="Calibri" pitchFamily="34" charset="-120"/>
               </a:rPr>
-              <a:t>Add knowledge</a:t>
+              <a:t>Demo 1: Build the agent</a:t>
             </a:r>
             <a:endParaRPr lang="en-US" sz="2800" dirty="0"/>
           </a:p>
@@ -3740,18 +5258,18 @@
         </p:nvSpPr>
         <p:spPr>
           <a:xfrm>
-            <a:off x="457200" y="1188720"/>
-            <a:ext cx="3931920" cy="2926080"/>
+            <a:off x="6035040" y="274320"/>
+            <a:ext cx="2651760" cy="457200"/>
           </a:xfrm>
           <a:prstGeom prst="rect">
             <a:avLst/>
           </a:prstGeom>
           <a:solidFill>
-            <a:srgbClr val="102235"/>
+            <a:srgbClr val="FF6B35"/>
           </a:solidFill>
-          <a:ln w="19050">
+          <a:ln w="12700">
             <a:solidFill>
-              <a:srgbClr val="4CAF82"/>
+              <a:srgbClr val="FF6B35"/>
             </a:solidFill>
             <a:prstDash val="solid"/>
           </a:ln>
@@ -3765,111 +5283,55 @@
         </p:nvSpPr>
         <p:spPr>
           <a:xfrm>
-            <a:off x="640080" y="1325880"/>
-            <a:ext cx="3566160" cy="457200"/>
-          </a:xfrm>
-          <a:prstGeom prst="rect">
-            <a:avLst/>
-          </a:prstGeom>
-          <a:noFill/>
-          <a:ln/>
-        </p:spPr>
-        <p:txBody>
-          <a:bodyPr wrap="square" lIns="0" tIns="0" rIns="0" bIns="0" rtlCol="0" anchor="t"/>
-          <a:lstStyle/>
-          <a:p>
-            <a:pPr indent="0" marL="0">
-              <a:buNone/>
-            </a:pPr>
-            <a:r>
-              <a:rPr lang="en-US" sz="2000" b="1" dirty="0">
-                <a:solidFill>
-                  <a:srgbClr val="4CAF82"/>
-                </a:solidFill>
-                <a:latin typeface="Calibri" pitchFamily="34" charset="0"/>
-                <a:ea typeface="Calibri" pitchFamily="34" charset="-122"/>
-                <a:cs typeface="Calibri" pitchFamily="34" charset="-120"/>
-              </a:rPr>
-              <a:t>Document (sample FAQ)</a:t>
-            </a:r>
-            <a:endParaRPr lang="en-US" sz="2000" dirty="0"/>
-          </a:p>
-        </p:txBody>
-      </p:sp>
-      <p:sp>
-        <p:nvSpPr>
-          <p:cNvPr id="7" name="Text 4"/>
-          <p:cNvSpPr txBox="1"/>
-          <p:nvPr/>
-        </p:nvSpPr>
-        <p:spPr>
-          <a:xfrm>
-            <a:off x="640080" y="1874520"/>
-            <a:ext cx="3566160" cy="2057400"/>
-          </a:xfrm>
-          <a:prstGeom prst="rect">
-            <a:avLst/>
-          </a:prstGeom>
-          <a:noFill/>
-          <a:ln/>
-        </p:spPr>
-        <p:txBody>
-          <a:bodyPr wrap="square" lIns="0" tIns="0" rIns="0" bIns="0" rtlCol="0" anchor="t"/>
-          <a:lstStyle/>
-          <a:p>
-            <a:pPr indent="0" marL="0">
-              <a:buNone/>
-            </a:pPr>
-            <a:r>
-              <a:rPr lang="en-US" sz="1600" dirty="0">
-                <a:solidFill>
-                  <a:srgbClr val="E8F4FD"/>
-                </a:solidFill>
-                <a:latin typeface="Calibri" pitchFamily="34" charset="0"/>
-                <a:ea typeface="Calibri" pitchFamily="34" charset="-122"/>
-                <a:cs typeface="Calibri" pitchFamily="34" charset="-120"/>
-              </a:rPr>
-              <a:t>Programme questions: format, session structure, materials, homework.</a:t>
-            </a:r>
-            <a:endParaRPr lang="en-US" sz="1600" dirty="0"/>
-          </a:p>
-          <a:p>
-            <a:pPr indent="0" marL="0">
-              <a:buNone/>
-            </a:pPr>
-            <a:r>
-              <a:rPr lang="en-US" sz="1600" dirty="0">
-                <a:solidFill>
-                  <a:srgbClr val="E8F4FD"/>
-                </a:solidFill>
-                <a:latin typeface="Calibri" pitchFamily="34" charset="0"/>
-                <a:ea typeface="Calibri" pitchFamily="34" charset="-122"/>
-                <a:cs typeface="Calibri" pitchFamily="34" charset="-120"/>
-              </a:rPr>
-              <a:t>Deliberately silent on fees and dates.</a:t>
-            </a:r>
-            <a:endParaRPr lang="en-US" sz="1600" dirty="0"/>
-          </a:p>
-        </p:txBody>
-      </p:sp>
-      <p:sp>
-        <p:nvSpPr>
-          <p:cNvPr id="8" name="Shape 5"/>
+            <a:off x="6035040" y="274320"/>
+            <a:ext cx="2651760" cy="457200"/>
+          </a:xfrm>
+          <a:prstGeom prst="rect">
+            <a:avLst/>
+          </a:prstGeom>
+          <a:noFill/>
+          <a:ln/>
+        </p:spPr>
+        <p:txBody>
+          <a:bodyPr wrap="square" lIns="0" tIns="0" rIns="0" bIns="0" rtlCol="0" anchor="ctr"/>
+          <a:lstStyle/>
+          <a:p>
+            <a:pPr algn="ctr" indent="0" marL="0">
+              <a:buNone/>
+            </a:pPr>
+            <a:r>
+              <a:rPr lang="en-US" sz="1200" b="1" dirty="0">
+                <a:solidFill>
+                  <a:srgbClr val="FFFFFF"/>
+                </a:solidFill>
+                <a:latin typeface="Calibri" pitchFamily="34" charset="0"/>
+                <a:ea typeface="Calibri" pitchFamily="34" charset="-122"/>
+                <a:cs typeface="Calibri" pitchFamily="34" charset="-120"/>
+              </a:rPr>
+              <a:t>SWITCH TO COPILOT STUDIO</a:t>
+            </a:r>
+            <a:endParaRPr lang="en-US" sz="1200" dirty="0"/>
+          </a:p>
+        </p:txBody>
+      </p:sp>
+      <p:sp>
+        <p:nvSpPr>
+          <p:cNvPr id="7" name="Shape 4"/>
           <p:cNvSpPr/>
           <p:nvPr/>
         </p:nvSpPr>
         <p:spPr>
           <a:xfrm>
-            <a:off x="4754880" y="1188720"/>
-            <a:ext cx="3931920" cy="2926080"/>
-          </a:xfrm>
-          <a:prstGeom prst="rect">
+            <a:off x="457200" y="1234440"/>
+            <a:ext cx="365760" cy="365760"/>
+          </a:xfrm>
+          <a:prstGeom prst="ellipse">
             <a:avLst/>
           </a:prstGeom>
           <a:solidFill>
-            <a:srgbClr val="102235"/>
+            <a:srgbClr val="00B4D8"/>
           </a:solidFill>
-          <a:ln w="19050">
+          <a:ln w="12700">
             <a:solidFill>
               <a:srgbClr val="00B4D8"/>
             </a:solidFill>
@@ -3879,14 +5341,53 @@
       </p:sp>
       <p:sp>
         <p:nvSpPr>
+          <p:cNvPr id="8" name="Text 5"/>
+          <p:cNvSpPr txBox="1"/>
+          <p:nvPr/>
+        </p:nvSpPr>
+        <p:spPr>
+          <a:xfrm>
+            <a:off x="457200" y="1234440"/>
+            <a:ext cx="365760" cy="365760"/>
+          </a:xfrm>
+          <a:prstGeom prst="rect">
+            <a:avLst/>
+          </a:prstGeom>
+          <a:noFill/>
+          <a:ln/>
+        </p:spPr>
+        <p:txBody>
+          <a:bodyPr wrap="square" lIns="0" tIns="0" rIns="0" bIns="0" rtlCol="0" anchor="ctr"/>
+          <a:lstStyle/>
+          <a:p>
+            <a:pPr algn="ctr" indent="0" marL="0">
+              <a:buNone/>
+            </a:pPr>
+            <a:r>
+              <a:rPr lang="en-US" sz="1400" b="1" dirty="0">
+                <a:solidFill>
+                  <a:srgbClr val="0A1628"/>
+                </a:solidFill>
+                <a:latin typeface="Calibri" pitchFamily="34" charset="0"/>
+                <a:ea typeface="Calibri" pitchFamily="34" charset="-122"/>
+                <a:cs typeface="Calibri" pitchFamily="34" charset="-120"/>
+              </a:rPr>
+              <a:t>1</a:t>
+            </a:r>
+            <a:endParaRPr lang="en-US" sz="1400" dirty="0"/>
+          </a:p>
+        </p:txBody>
+      </p:sp>
+      <p:sp>
+        <p:nvSpPr>
           <p:cNvPr id="9" name="Text 6"/>
           <p:cNvSpPr txBox="1"/>
           <p:nvPr/>
         </p:nvSpPr>
         <p:spPr>
           <a:xfrm>
-            <a:off x="4937760" y="1325880"/>
-            <a:ext cx="3566160" cy="457200"/>
+            <a:off x="1005840" y="1188720"/>
+            <a:ext cx="7680960" cy="457200"/>
           </a:xfrm>
           <a:prstGeom prst="rect">
             <a:avLst/>
@@ -3902,30 +5403,94 @@
               <a:buNone/>
             </a:pPr>
             <a:r>
-              <a:rPr lang="en-US" sz="2000" b="1" dirty="0">
-                <a:solidFill>
-                  <a:srgbClr val="00B4D8"/>
-                </a:solidFill>
-                <a:latin typeface="Calibri" pitchFamily="34" charset="0"/>
-                <a:ea typeface="Calibri" pitchFamily="34" charset="-122"/>
-                <a:cs typeface="Calibri" pitchFamily="34" charset="-120"/>
-              </a:rPr>
-              <a:t>Public website</a:t>
-            </a:r>
-            <a:endParaRPr lang="en-US" sz="2000" dirty="0"/>
-          </a:p>
-        </p:txBody>
-      </p:sp>
-      <p:sp>
-        <p:nvSpPr>
-          <p:cNvPr id="10" name="Text 7"/>
-          <p:cNvSpPr txBox="1"/>
-          <p:nvPr/>
-        </p:nvSpPr>
-        <p:spPr>
-          <a:xfrm>
-            <a:off x="4937760" y="1874520"/>
-            <a:ext cx="3566160" cy="2057400"/>
+              <a:rPr lang="en-US" sz="1600" b="1" dirty="0">
+                <a:solidFill>
+                  <a:srgbClr val="E8F4FD"/>
+                </a:solidFill>
+                <a:latin typeface="Calibri" pitchFamily="34" charset="0"/>
+                <a:ea typeface="Calibri" pitchFamily="34" charset="-122"/>
+                <a:cs typeface="Calibri" pitchFamily="34" charset="-120"/>
+              </a:rPr>
+              <a:t>Create: New agent, then Configure</a:t>
+            </a:r>
+            <a:endParaRPr lang="en-US" sz="1600" dirty="0"/>
+          </a:p>
+        </p:txBody>
+      </p:sp>
+      <p:sp>
+        <p:nvSpPr>
+          <p:cNvPr id="10" name="Shape 7"/>
+          <p:cNvSpPr/>
+          <p:nvPr/>
+        </p:nvSpPr>
+        <p:spPr>
+          <a:xfrm>
+            <a:off x="457200" y="1737360"/>
+            <a:ext cx="365760" cy="365760"/>
+          </a:xfrm>
+          <a:prstGeom prst="ellipse">
+            <a:avLst/>
+          </a:prstGeom>
+          <a:solidFill>
+            <a:srgbClr val="00B4D8"/>
+          </a:solidFill>
+          <a:ln w="12700">
+            <a:solidFill>
+              <a:srgbClr val="00B4D8"/>
+            </a:solidFill>
+            <a:prstDash val="solid"/>
+          </a:ln>
+        </p:spPr>
+      </p:sp>
+      <p:sp>
+        <p:nvSpPr>
+          <p:cNvPr id="11" name="Text 8"/>
+          <p:cNvSpPr txBox="1"/>
+          <p:nvPr/>
+        </p:nvSpPr>
+        <p:spPr>
+          <a:xfrm>
+            <a:off x="457200" y="1737360"/>
+            <a:ext cx="365760" cy="365760"/>
+          </a:xfrm>
+          <a:prstGeom prst="rect">
+            <a:avLst/>
+          </a:prstGeom>
+          <a:noFill/>
+          <a:ln/>
+        </p:spPr>
+        <p:txBody>
+          <a:bodyPr wrap="square" lIns="0" tIns="0" rIns="0" bIns="0" rtlCol="0" anchor="ctr"/>
+          <a:lstStyle/>
+          <a:p>
+            <a:pPr algn="ctr" indent="0" marL="0">
+              <a:buNone/>
+            </a:pPr>
+            <a:r>
+              <a:rPr lang="en-US" sz="1400" b="1" dirty="0">
+                <a:solidFill>
+                  <a:srgbClr val="0A1628"/>
+                </a:solidFill>
+                <a:latin typeface="Calibri" pitchFamily="34" charset="0"/>
+                <a:ea typeface="Calibri" pitchFamily="34" charset="-122"/>
+                <a:cs typeface="Calibri" pitchFamily="34" charset="-120"/>
+              </a:rPr>
+              <a:t>2</a:t>
+            </a:r>
+            <a:endParaRPr lang="en-US" sz="1400" dirty="0"/>
+          </a:p>
+        </p:txBody>
+      </p:sp>
+      <p:sp>
+        <p:nvSpPr>
+          <p:cNvPr id="12" name="Text 9"/>
+          <p:cNvSpPr txBox="1"/>
+          <p:nvPr/>
+        </p:nvSpPr>
+        <p:spPr>
+          <a:xfrm>
+            <a:off x="1005840" y="1691640"/>
+            <a:ext cx="7680960" cy="457200"/>
           </a:xfrm>
           <a:prstGeom prst="rect">
             <a:avLst/>
@@ -3941,7 +5506,7 @@
               <a:buNone/>
             </a:pPr>
             <a:r>
-              <a:rPr lang="en-US" sz="1600" dirty="0">
+              <a:rPr lang="en-US" sz="1600" b="1" dirty="0">
                 <a:solidFill>
                   <a:srgbClr val="E8F4FD"/>
                 </a:solidFill>
@@ -3949,16 +5514,102 @@
                 <a:ea typeface="Calibri" pitchFamily="34" charset="-122"/>
                 <a:cs typeface="Calibri" pitchFamily="34" charset="-120"/>
               </a:rPr>
-              <a:t>Microsoft Learn: Copilot Studio docs.</a:t>
+              <a:t>Name: AI Pioneers Learner Concierge</a:t>
             </a:r>
             <a:endParaRPr lang="en-US" sz="1600" dirty="0"/>
           </a:p>
-          <a:p>
-            <a:pPr indent="0" marL="0">
-              <a:buNone/>
-            </a:pPr>
-            <a:r>
-              <a:rPr lang="en-US" sz="1600" dirty="0">
+        </p:txBody>
+      </p:sp>
+      <p:sp>
+        <p:nvSpPr>
+          <p:cNvPr id="13" name="Shape 10"/>
+          <p:cNvSpPr/>
+          <p:nvPr/>
+        </p:nvSpPr>
+        <p:spPr>
+          <a:xfrm>
+            <a:off x="457200" y="2240280"/>
+            <a:ext cx="365760" cy="365760"/>
+          </a:xfrm>
+          <a:prstGeom prst="ellipse">
+            <a:avLst/>
+          </a:prstGeom>
+          <a:solidFill>
+            <a:srgbClr val="00B4D8"/>
+          </a:solidFill>
+          <a:ln w="12700">
+            <a:solidFill>
+              <a:srgbClr val="00B4D8"/>
+            </a:solidFill>
+            <a:prstDash val="solid"/>
+          </a:ln>
+        </p:spPr>
+      </p:sp>
+      <p:sp>
+        <p:nvSpPr>
+          <p:cNvPr id="14" name="Text 11"/>
+          <p:cNvSpPr txBox="1"/>
+          <p:nvPr/>
+        </p:nvSpPr>
+        <p:spPr>
+          <a:xfrm>
+            <a:off x="457200" y="2240280"/>
+            <a:ext cx="365760" cy="365760"/>
+          </a:xfrm>
+          <a:prstGeom prst="rect">
+            <a:avLst/>
+          </a:prstGeom>
+          <a:noFill/>
+          <a:ln/>
+        </p:spPr>
+        <p:txBody>
+          <a:bodyPr wrap="square" lIns="0" tIns="0" rIns="0" bIns="0" rtlCol="0" anchor="ctr"/>
+          <a:lstStyle/>
+          <a:p>
+            <a:pPr algn="ctr" indent="0" marL="0">
+              <a:buNone/>
+            </a:pPr>
+            <a:r>
+              <a:rPr lang="en-US" sz="1400" b="1" dirty="0">
+                <a:solidFill>
+                  <a:srgbClr val="0A1628"/>
+                </a:solidFill>
+                <a:latin typeface="Calibri" pitchFamily="34" charset="0"/>
+                <a:ea typeface="Calibri" pitchFamily="34" charset="-122"/>
+                <a:cs typeface="Calibri" pitchFamily="34" charset="-120"/>
+              </a:rPr>
+              <a:t>3</a:t>
+            </a:r>
+            <a:endParaRPr lang="en-US" sz="1400" dirty="0"/>
+          </a:p>
+        </p:txBody>
+      </p:sp>
+      <p:sp>
+        <p:nvSpPr>
+          <p:cNvPr id="15" name="Text 12"/>
+          <p:cNvSpPr txBox="1"/>
+          <p:nvPr/>
+        </p:nvSpPr>
+        <p:spPr>
+          <a:xfrm>
+            <a:off x="1005840" y="2194560"/>
+            <a:ext cx="7680960" cy="457200"/>
+          </a:xfrm>
+          <a:prstGeom prst="rect">
+            <a:avLst/>
+          </a:prstGeom>
+          <a:noFill/>
+          <a:ln/>
+        </p:spPr>
+        <p:txBody>
+          <a:bodyPr wrap="square" lIns="0" tIns="0" rIns="0" bIns="0" rtlCol="0" anchor="t"/>
+          <a:lstStyle/>
+          <a:p>
+            <a:pPr indent="0" marL="0">
+              <a:buNone/>
+            </a:pPr>
+            <a:r>
+              <a:rPr lang="en-US" sz="1600" b="1" dirty="0">
                 <a:solidFill>
                   <a:srgbClr val="E8F4FD"/>
                 </a:solidFill>
@@ -3966,9 +5617,357 @@
                 <a:ea typeface="Calibri" pitchFamily="34" charset="-122"/>
                 <a:cs typeface="Calibri" pitchFamily="34" charset="-120"/>
               </a:rPr>
-              <a:t>Needs Bing-indexed pages, up to two URL levels, no login-only sites.</a:t>
+              <a:t>Description: one line on who it helps and what it does</a:t>
             </a:r>
             <a:endParaRPr lang="en-US" sz="1600" dirty="0"/>
+          </a:p>
+        </p:txBody>
+      </p:sp>
+      <p:sp>
+        <p:nvSpPr>
+          <p:cNvPr id="16" name="Shape 13"/>
+          <p:cNvSpPr/>
+          <p:nvPr/>
+        </p:nvSpPr>
+        <p:spPr>
+          <a:xfrm>
+            <a:off x="457200" y="2743200"/>
+            <a:ext cx="365760" cy="365760"/>
+          </a:xfrm>
+          <a:prstGeom prst="ellipse">
+            <a:avLst/>
+          </a:prstGeom>
+          <a:solidFill>
+            <a:srgbClr val="00B4D8"/>
+          </a:solidFill>
+          <a:ln w="12700">
+            <a:solidFill>
+              <a:srgbClr val="00B4D8"/>
+            </a:solidFill>
+            <a:prstDash val="solid"/>
+          </a:ln>
+        </p:spPr>
+      </p:sp>
+      <p:sp>
+        <p:nvSpPr>
+          <p:cNvPr id="17" name="Text 14"/>
+          <p:cNvSpPr txBox="1"/>
+          <p:nvPr/>
+        </p:nvSpPr>
+        <p:spPr>
+          <a:xfrm>
+            <a:off x="457200" y="2743200"/>
+            <a:ext cx="365760" cy="365760"/>
+          </a:xfrm>
+          <a:prstGeom prst="rect">
+            <a:avLst/>
+          </a:prstGeom>
+          <a:noFill/>
+          <a:ln/>
+        </p:spPr>
+        <p:txBody>
+          <a:bodyPr wrap="square" lIns="0" tIns="0" rIns="0" bIns="0" rtlCol="0" anchor="ctr"/>
+          <a:lstStyle/>
+          <a:p>
+            <a:pPr algn="ctr" indent="0" marL="0">
+              <a:buNone/>
+            </a:pPr>
+            <a:r>
+              <a:rPr lang="en-US" sz="1400" b="1" dirty="0">
+                <a:solidFill>
+                  <a:srgbClr val="0A1628"/>
+                </a:solidFill>
+                <a:latin typeface="Calibri" pitchFamily="34" charset="0"/>
+                <a:ea typeface="Calibri" pitchFamily="34" charset="-122"/>
+                <a:cs typeface="Calibri" pitchFamily="34" charset="-120"/>
+              </a:rPr>
+              <a:t>4</a:t>
+            </a:r>
+            <a:endParaRPr lang="en-US" sz="1400" dirty="0"/>
+          </a:p>
+        </p:txBody>
+      </p:sp>
+      <p:sp>
+        <p:nvSpPr>
+          <p:cNvPr id="18" name="Text 15"/>
+          <p:cNvSpPr txBox="1"/>
+          <p:nvPr/>
+        </p:nvSpPr>
+        <p:spPr>
+          <a:xfrm>
+            <a:off x="1005840" y="2697480"/>
+            <a:ext cx="7680960" cy="457200"/>
+          </a:xfrm>
+          <a:prstGeom prst="rect">
+            <a:avLst/>
+          </a:prstGeom>
+          <a:noFill/>
+          <a:ln/>
+        </p:spPr>
+        <p:txBody>
+          <a:bodyPr wrap="square" lIns="0" tIns="0" rIns="0" bIns="0" rtlCol="0" anchor="t"/>
+          <a:lstStyle/>
+          <a:p>
+            <a:pPr indent="0" marL="0">
+              <a:buNone/>
+            </a:pPr>
+            <a:r>
+              <a:rPr lang="en-US" sz="1600" b="1" dirty="0">
+                <a:solidFill>
+                  <a:srgbClr val="E8F4FD"/>
+                </a:solidFill>
+                <a:latin typeface="Calibri" pitchFamily="34" charset="0"/>
+                <a:ea typeface="Calibri" pitchFamily="34" charset="-122"/>
+                <a:cs typeface="Calibri" pitchFamily="34" charset="-120"/>
+              </a:rPr>
+              <a:t>Instructions: paste from the Demo Runbook, section 3</a:t>
+            </a:r>
+            <a:endParaRPr lang="en-US" sz="1600" dirty="0"/>
+          </a:p>
+        </p:txBody>
+      </p:sp>
+      <p:sp>
+        <p:nvSpPr>
+          <p:cNvPr id="19" name="Shape 16"/>
+          <p:cNvSpPr/>
+          <p:nvPr/>
+        </p:nvSpPr>
+        <p:spPr>
+          <a:xfrm>
+            <a:off x="457200" y="3246120"/>
+            <a:ext cx="365760" cy="365760"/>
+          </a:xfrm>
+          <a:prstGeom prst="ellipse">
+            <a:avLst/>
+          </a:prstGeom>
+          <a:solidFill>
+            <a:srgbClr val="00B4D8"/>
+          </a:solidFill>
+          <a:ln w="12700">
+            <a:solidFill>
+              <a:srgbClr val="00B4D8"/>
+            </a:solidFill>
+            <a:prstDash val="solid"/>
+          </a:ln>
+        </p:spPr>
+      </p:sp>
+      <p:sp>
+        <p:nvSpPr>
+          <p:cNvPr id="20" name="Text 17"/>
+          <p:cNvSpPr txBox="1"/>
+          <p:nvPr/>
+        </p:nvSpPr>
+        <p:spPr>
+          <a:xfrm>
+            <a:off x="457200" y="3246120"/>
+            <a:ext cx="365760" cy="365760"/>
+          </a:xfrm>
+          <a:prstGeom prst="rect">
+            <a:avLst/>
+          </a:prstGeom>
+          <a:noFill/>
+          <a:ln/>
+        </p:spPr>
+        <p:txBody>
+          <a:bodyPr wrap="square" lIns="0" tIns="0" rIns="0" bIns="0" rtlCol="0" anchor="ctr"/>
+          <a:lstStyle/>
+          <a:p>
+            <a:pPr algn="ctr" indent="0" marL="0">
+              <a:buNone/>
+            </a:pPr>
+            <a:r>
+              <a:rPr lang="en-US" sz="1400" b="1" dirty="0">
+                <a:solidFill>
+                  <a:srgbClr val="0A1628"/>
+                </a:solidFill>
+                <a:latin typeface="Calibri" pitchFamily="34" charset="0"/>
+                <a:ea typeface="Calibri" pitchFamily="34" charset="-122"/>
+                <a:cs typeface="Calibri" pitchFamily="34" charset="-120"/>
+              </a:rPr>
+              <a:t>5</a:t>
+            </a:r>
+            <a:endParaRPr lang="en-US" sz="1400" dirty="0"/>
+          </a:p>
+        </p:txBody>
+      </p:sp>
+      <p:sp>
+        <p:nvSpPr>
+          <p:cNvPr id="21" name="Text 18"/>
+          <p:cNvSpPr txBox="1"/>
+          <p:nvPr/>
+        </p:nvSpPr>
+        <p:spPr>
+          <a:xfrm>
+            <a:off x="1005840" y="3200400"/>
+            <a:ext cx="7680960" cy="457200"/>
+          </a:xfrm>
+          <a:prstGeom prst="rect">
+            <a:avLst/>
+          </a:prstGeom>
+          <a:noFill/>
+          <a:ln/>
+        </p:spPr>
+        <p:txBody>
+          <a:bodyPr wrap="square" lIns="0" tIns="0" rIns="0" bIns="0" rtlCol="0" anchor="t"/>
+          <a:lstStyle/>
+          <a:p>
+            <a:pPr indent="0" marL="0">
+              <a:buNone/>
+            </a:pPr>
+            <a:r>
+              <a:rPr lang="en-US" sz="1600" b="1" dirty="0">
+                <a:solidFill>
+                  <a:srgbClr val="E8F4FD"/>
+                </a:solidFill>
+                <a:latin typeface="Calibri" pitchFamily="34" charset="0"/>
+                <a:ea typeface="Calibri" pitchFamily="34" charset="-122"/>
+                <a:cs typeface="Calibri" pitchFamily="34" charset="-120"/>
+              </a:rPr>
+              <a:t>Open web search: OFF</a:t>
+            </a:r>
+            <a:endParaRPr lang="en-US" sz="1600" dirty="0"/>
+          </a:p>
+        </p:txBody>
+      </p:sp>
+      <p:sp>
+        <p:nvSpPr>
+          <p:cNvPr id="22" name="Shape 19"/>
+          <p:cNvSpPr/>
+          <p:nvPr/>
+        </p:nvSpPr>
+        <p:spPr>
+          <a:xfrm>
+            <a:off x="457200" y="3749040"/>
+            <a:ext cx="365760" cy="365760"/>
+          </a:xfrm>
+          <a:prstGeom prst="ellipse">
+            <a:avLst/>
+          </a:prstGeom>
+          <a:solidFill>
+            <a:srgbClr val="00B4D8"/>
+          </a:solidFill>
+          <a:ln w="12700">
+            <a:solidFill>
+              <a:srgbClr val="00B4D8"/>
+            </a:solidFill>
+            <a:prstDash val="solid"/>
+          </a:ln>
+        </p:spPr>
+      </p:sp>
+      <p:sp>
+        <p:nvSpPr>
+          <p:cNvPr id="23" name="Text 20"/>
+          <p:cNvSpPr txBox="1"/>
+          <p:nvPr/>
+        </p:nvSpPr>
+        <p:spPr>
+          <a:xfrm>
+            <a:off x="457200" y="3749040"/>
+            <a:ext cx="365760" cy="365760"/>
+          </a:xfrm>
+          <a:prstGeom prst="rect">
+            <a:avLst/>
+          </a:prstGeom>
+          <a:noFill/>
+          <a:ln/>
+        </p:spPr>
+        <p:txBody>
+          <a:bodyPr wrap="square" lIns="0" tIns="0" rIns="0" bIns="0" rtlCol="0" anchor="ctr"/>
+          <a:lstStyle/>
+          <a:p>
+            <a:pPr algn="ctr" indent="0" marL="0">
+              <a:buNone/>
+            </a:pPr>
+            <a:r>
+              <a:rPr lang="en-US" sz="1400" b="1" dirty="0">
+                <a:solidFill>
+                  <a:srgbClr val="0A1628"/>
+                </a:solidFill>
+                <a:latin typeface="Calibri" pitchFamily="34" charset="0"/>
+                <a:ea typeface="Calibri" pitchFamily="34" charset="-122"/>
+                <a:cs typeface="Calibri" pitchFamily="34" charset="-120"/>
+              </a:rPr>
+              <a:t>6</a:t>
+            </a:r>
+            <a:endParaRPr lang="en-US" sz="1400" dirty="0"/>
+          </a:p>
+        </p:txBody>
+      </p:sp>
+      <p:sp>
+        <p:nvSpPr>
+          <p:cNvPr id="24" name="Text 21"/>
+          <p:cNvSpPr txBox="1"/>
+          <p:nvPr/>
+        </p:nvSpPr>
+        <p:spPr>
+          <a:xfrm>
+            <a:off x="1005840" y="3703320"/>
+            <a:ext cx="7680960" cy="457200"/>
+          </a:xfrm>
+          <a:prstGeom prst="rect">
+            <a:avLst/>
+          </a:prstGeom>
+          <a:noFill/>
+          <a:ln/>
+        </p:spPr>
+        <p:txBody>
+          <a:bodyPr wrap="square" lIns="0" tIns="0" rIns="0" bIns="0" rtlCol="0" anchor="t"/>
+          <a:lstStyle/>
+          <a:p>
+            <a:pPr indent="0" marL="0">
+              <a:buNone/>
+            </a:pPr>
+            <a:r>
+              <a:rPr lang="en-US" sz="1600" b="1" dirty="0">
+                <a:solidFill>
+                  <a:srgbClr val="E8F4FD"/>
+                </a:solidFill>
+                <a:latin typeface="Calibri" pitchFamily="34" charset="0"/>
+                <a:ea typeface="Calibri" pitchFamily="34" charset="-122"/>
+                <a:cs typeface="Calibri" pitchFamily="34" charset="-120"/>
+              </a:rPr>
+              <a:t>Create the agent</a:t>
+            </a:r>
+            <a:endParaRPr lang="en-US" sz="1600" dirty="0"/>
+          </a:p>
+        </p:txBody>
+      </p:sp>
+      <p:sp>
+        <p:nvSpPr>
+          <p:cNvPr id="25" name="Text 22"/>
+          <p:cNvSpPr txBox="1"/>
+          <p:nvPr/>
+        </p:nvSpPr>
+        <p:spPr>
+          <a:xfrm>
+            <a:off x="457200" y="4572000"/>
+            <a:ext cx="8229600" cy="274320"/>
+          </a:xfrm>
+          <a:prstGeom prst="rect">
+            <a:avLst/>
+          </a:prstGeom>
+          <a:noFill/>
+          <a:ln/>
+        </p:spPr>
+        <p:txBody>
+          <a:bodyPr wrap="square" lIns="0" tIns="0" rIns="0" bIns="0" rtlCol="0" anchor="ctr"/>
+          <a:lstStyle/>
+          <a:p>
+            <a:pPr indent="0" marL="0">
+              <a:buNone/>
+            </a:pPr>
+            <a:r>
+              <a:rPr lang="en-US" sz="1200" i="1" dirty="0">
+                <a:solidFill>
+                  <a:srgbClr val="90B8D4"/>
+                </a:solidFill>
+                <a:latin typeface="Calibri" pitchFamily="34" charset="0"/>
+                <a:ea typeface="Calibri" pitchFamily="34" charset="-122"/>
+                <a:cs typeface="Calibri" pitchFamily="34" charset="-120"/>
+              </a:rPr>
+              <a:t>Then return to the slides</a:t>
+            </a:r>
+            <a:endParaRPr lang="en-US" sz="1200" dirty="0"/>
           </a:p>
         </p:txBody>
       </p:sp>
@@ -4037,7 +6036,7 @@
                 <a:ea typeface="Calibri" pitchFamily="34" charset="-122"/>
                 <a:cs typeface="Calibri" pitchFamily="34" charset="-120"/>
               </a:rPr>
-              <a:t>Test it: refusals too</a:t>
+              <a:t>Add knowledge</a:t>
             </a:r>
             <a:endParaRPr lang="en-US" sz="2800" dirty="0"/>
           </a:p>
@@ -4077,7 +6076,7 @@
         <p:spPr>
           <a:xfrm>
             <a:off x="457200" y="1188720"/>
-            <a:ext cx="3931920" cy="1463040"/>
+            <a:ext cx="3931920" cy="2926080"/>
           </a:xfrm>
           <a:prstGeom prst="rect">
             <a:avLst/>
@@ -4126,7 +6125,7 @@
                 <a:ea typeface="Calibri" pitchFamily="34" charset="-122"/>
                 <a:cs typeface="Calibri" pitchFamily="34" charset="-120"/>
               </a:rPr>
-              <a:t>From the document</a:t>
+              <a:t>Document (sample FAQ)</a:t>
             </a:r>
             <a:endParaRPr lang="en-US" sz="2000" dirty="0"/>
           </a:p>
@@ -4141,7 +6140,7 @@
         <p:spPr>
           <a:xfrm>
             <a:off x="640080" y="1874520"/>
-            <a:ext cx="3566160" cy="594360"/>
+            <a:ext cx="3566160" cy="2057400"/>
           </a:xfrm>
           <a:prstGeom prst="rect">
             <a:avLst/>
@@ -4165,7 +6164,24 @@
                 <a:ea typeface="Calibri" pitchFamily="34" charset="-122"/>
                 <a:cs typeface="Calibri" pitchFamily="34" charset="-120"/>
               </a:rPr>
-              <a:t>How is each session structured?</a:t>
+              <a:t>Programme questions: format, session structure, materials, homework.</a:t>
+            </a:r>
+            <a:endParaRPr lang="en-US" sz="1600" dirty="0"/>
+          </a:p>
+          <a:p>
+            <a:pPr indent="0" marL="0">
+              <a:buNone/>
+            </a:pPr>
+            <a:r>
+              <a:rPr lang="en-US" sz="1600" dirty="0">
+                <a:solidFill>
+                  <a:srgbClr val="E8F4FD"/>
+                </a:solidFill>
+                <a:latin typeface="Calibri" pitchFamily="34" charset="0"/>
+                <a:ea typeface="Calibri" pitchFamily="34" charset="-122"/>
+                <a:cs typeface="Calibri" pitchFamily="34" charset="-120"/>
+              </a:rPr>
+              <a:t>Deliberately silent on fees and dates.</a:t>
             </a:r>
             <a:endParaRPr lang="en-US" sz="1600" dirty="0"/>
           </a:p>
@@ -4180,7 +6196,7 @@
         <p:spPr>
           <a:xfrm>
             <a:off x="4754880" y="1188720"/>
-            <a:ext cx="3931920" cy="1463040"/>
+            <a:ext cx="3931920" cy="2926080"/>
           </a:xfrm>
           <a:prstGeom prst="rect">
             <a:avLst/>
@@ -4229,7 +6245,7 @@
                 <a:ea typeface="Calibri" pitchFamily="34" charset="-122"/>
                 <a:cs typeface="Calibri" pitchFamily="34" charset="-120"/>
               </a:rPr>
-              <a:t>From the website</a:t>
+              <a:t>Public website</a:t>
             </a:r>
             <a:endParaRPr lang="en-US" sz="2000" dirty="0"/>
           </a:p>
@@ -4244,7 +6260,7 @@
         <p:spPr>
           <a:xfrm>
             <a:off x="4937760" y="1874520"/>
-            <a:ext cx="3566160" cy="594360"/>
+            <a:ext cx="3566160" cy="2057400"/>
           </a:xfrm>
           <a:prstGeom prst="rect">
             <a:avLst/>
@@ -4268,96 +6284,10 @@
                 <a:ea typeface="Calibri" pitchFamily="34" charset="-122"/>
                 <a:cs typeface="Calibri" pitchFamily="34" charset="-120"/>
               </a:rPr>
-              <a:t>How do I add a public website as knowledge?</a:t>
+              <a:t>Microsoft Learn: Copilot Studio docs.</a:t>
             </a:r>
             <a:endParaRPr lang="en-US" sz="1600" dirty="0"/>
           </a:p>
-        </p:txBody>
-      </p:sp>
-      <p:sp>
-        <p:nvSpPr>
-          <p:cNvPr id="11" name="Shape 8"/>
-          <p:cNvSpPr/>
-          <p:nvPr/>
-        </p:nvSpPr>
-        <p:spPr>
-          <a:xfrm>
-            <a:off x="457200" y="2926080"/>
-            <a:ext cx="3931920" cy="1463040"/>
-          </a:xfrm>
-          <a:prstGeom prst="rect">
-            <a:avLst/>
-          </a:prstGeom>
-          <a:solidFill>
-            <a:srgbClr val="102235"/>
-          </a:solidFill>
-          <a:ln w="19050">
-            <a:solidFill>
-              <a:srgbClr val="FF6B35"/>
-            </a:solidFill>
-            <a:prstDash val="solid"/>
-          </a:ln>
-        </p:spPr>
-      </p:sp>
-      <p:sp>
-        <p:nvSpPr>
-          <p:cNvPr id="12" name="Text 9"/>
-          <p:cNvSpPr txBox="1"/>
-          <p:nvPr/>
-        </p:nvSpPr>
-        <p:spPr>
-          <a:xfrm>
-            <a:off x="640080" y="3063240"/>
-            <a:ext cx="3566160" cy="457200"/>
-          </a:xfrm>
-          <a:prstGeom prst="rect">
-            <a:avLst/>
-          </a:prstGeom>
-          <a:noFill/>
-          <a:ln/>
-        </p:spPr>
-        <p:txBody>
-          <a:bodyPr wrap="square" lIns="0" tIns="0" rIns="0" bIns="0" rtlCol="0" anchor="t"/>
-          <a:lstStyle/>
-          <a:p>
-            <a:pPr indent="0" marL="0">
-              <a:buNone/>
-            </a:pPr>
-            <a:r>
-              <a:rPr lang="en-US" sz="2000" b="1" dirty="0">
-                <a:solidFill>
-                  <a:srgbClr val="FF6B35"/>
-                </a:solidFill>
-                <a:latin typeface="Calibri" pitchFamily="34" charset="0"/>
-                <a:ea typeface="Calibri" pitchFamily="34" charset="-122"/>
-                <a:cs typeface="Calibri" pitchFamily="34" charset="-120"/>
-              </a:rPr>
-              <a:t>Not in any source</a:t>
-            </a:r>
-            <a:endParaRPr lang="en-US" sz="2000" dirty="0"/>
-          </a:p>
-        </p:txBody>
-      </p:sp>
-      <p:sp>
-        <p:nvSpPr>
-          <p:cNvPr id="13" name="Text 10"/>
-          <p:cNvSpPr txBox="1"/>
-          <p:nvPr/>
-        </p:nvSpPr>
-        <p:spPr>
-          <a:xfrm>
-            <a:off x="640080" y="3611880"/>
-            <a:ext cx="3566160" cy="594360"/>
-          </a:xfrm>
-          <a:prstGeom prst="rect">
-            <a:avLst/>
-          </a:prstGeom>
-          <a:noFill/>
-          <a:ln/>
-        </p:spPr>
-        <p:txBody>
-          <a:bodyPr wrap="square" lIns="0" tIns="0" rIns="0" bIns="0" rtlCol="0" anchor="t"/>
-          <a:lstStyle/>
           <a:p>
             <a:pPr indent="0" marL="0">
               <a:buNone/>
@@ -4371,110 +6301,7 @@
                 <a:ea typeface="Calibri" pitchFamily="34" charset="-122"/>
                 <a:cs typeface="Calibri" pitchFamily="34" charset="-120"/>
               </a:rPr>
-              <a:t>How much does it cost? Must decline</a:t>
-            </a:r>
-            <a:endParaRPr lang="en-US" sz="1600" dirty="0"/>
-          </a:p>
-        </p:txBody>
-      </p:sp>
-      <p:sp>
-        <p:nvSpPr>
-          <p:cNvPr id="14" name="Shape 11"/>
-          <p:cNvSpPr/>
-          <p:nvPr/>
-        </p:nvSpPr>
-        <p:spPr>
-          <a:xfrm>
-            <a:off x="4754880" y="2926080"/>
-            <a:ext cx="3931920" cy="1463040"/>
-          </a:xfrm>
-          <a:prstGeom prst="rect">
-            <a:avLst/>
-          </a:prstGeom>
-          <a:solidFill>
-            <a:srgbClr val="102235"/>
-          </a:solidFill>
-          <a:ln w="19050">
-            <a:solidFill>
-              <a:srgbClr val="9B72CF"/>
-            </a:solidFill>
-            <a:prstDash val="solid"/>
-          </a:ln>
-        </p:spPr>
-      </p:sp>
-      <p:sp>
-        <p:nvSpPr>
-          <p:cNvPr id="15" name="Text 12"/>
-          <p:cNvSpPr txBox="1"/>
-          <p:nvPr/>
-        </p:nvSpPr>
-        <p:spPr>
-          <a:xfrm>
-            <a:off x="4937760" y="3063240"/>
-            <a:ext cx="3566160" cy="457200"/>
-          </a:xfrm>
-          <a:prstGeom prst="rect">
-            <a:avLst/>
-          </a:prstGeom>
-          <a:noFill/>
-          <a:ln/>
-        </p:spPr>
-        <p:txBody>
-          <a:bodyPr wrap="square" lIns="0" tIns="0" rIns="0" bIns="0" rtlCol="0" anchor="t"/>
-          <a:lstStyle/>
-          <a:p>
-            <a:pPr indent="0" marL="0">
-              <a:buNone/>
-            </a:pPr>
-            <a:r>
-              <a:rPr lang="en-US" sz="2000" b="1" dirty="0">
-                <a:solidFill>
-                  <a:srgbClr val="9B72CF"/>
-                </a:solidFill>
-                <a:latin typeface="Calibri" pitchFamily="34" charset="0"/>
-                <a:ea typeface="Calibri" pitchFamily="34" charset="-122"/>
-                <a:cs typeface="Calibri" pitchFamily="34" charset="-120"/>
-              </a:rPr>
-              <a:t>Out of scope</a:t>
-            </a:r>
-            <a:endParaRPr lang="en-US" sz="2000" dirty="0"/>
-          </a:p>
-        </p:txBody>
-      </p:sp>
-      <p:sp>
-        <p:nvSpPr>
-          <p:cNvPr id="16" name="Text 13"/>
-          <p:cNvSpPr txBox="1"/>
-          <p:nvPr/>
-        </p:nvSpPr>
-        <p:spPr>
-          <a:xfrm>
-            <a:off x="4937760" y="3611880"/>
-            <a:ext cx="3566160" cy="594360"/>
-          </a:xfrm>
-          <a:prstGeom prst="rect">
-            <a:avLst/>
-          </a:prstGeom>
-          <a:noFill/>
-          <a:ln/>
-        </p:spPr>
-        <p:txBody>
-          <a:bodyPr wrap="square" lIns="0" tIns="0" rIns="0" bIns="0" rtlCol="0" anchor="t"/>
-          <a:lstStyle/>
-          <a:p>
-            <a:pPr indent="0" marL="0">
-              <a:buNone/>
-            </a:pPr>
-            <a:r>
-              <a:rPr lang="en-US" sz="1600" dirty="0">
-                <a:solidFill>
-                  <a:srgbClr val="E8F4FD"/>
-                </a:solidFill>
-                <a:latin typeface="Calibri" pitchFamily="34" charset="0"/>
-                <a:ea typeface="Calibri" pitchFamily="34" charset="-122"/>
-                <a:cs typeface="Calibri" pitchFamily="34" charset="-120"/>
-              </a:rPr>
-              <a:t>A political question. Must decline</a:t>
+              <a:t>Needs Bing-indexed pages, up to two URL levels, no login-only sites.</a:t>
             </a:r>
             <a:endParaRPr lang="en-US" sz="1600" dirty="0"/>
           </a:p>
@@ -4545,7 +6372,7 @@
                 <a:ea typeface="Calibri" pitchFamily="34" charset="-122"/>
                 <a:cs typeface="Calibri" pitchFamily="34" charset="-120"/>
               </a:rPr>
-              <a:t>What can go wrong, and takeaways</a:t>
+              <a:t>Demo 2: Add knowledge</a:t>
             </a:r>
             <a:endParaRPr lang="en-US" sz="2800" dirty="0"/>
           </a:p>
@@ -4584,8 +6411,859 @@
         </p:nvSpPr>
         <p:spPr>
           <a:xfrm>
+            <a:off x="6035040" y="274320"/>
+            <a:ext cx="2651760" cy="457200"/>
+          </a:xfrm>
+          <a:prstGeom prst="rect">
+            <a:avLst/>
+          </a:prstGeom>
+          <a:solidFill>
+            <a:srgbClr val="FF6B35"/>
+          </a:solidFill>
+          <a:ln w="12700">
+            <a:solidFill>
+              <a:srgbClr val="FF6B35"/>
+            </a:solidFill>
+            <a:prstDash val="solid"/>
+          </a:ln>
+        </p:spPr>
+      </p:sp>
+      <p:sp>
+        <p:nvSpPr>
+          <p:cNvPr id="6" name="Text 3"/>
+          <p:cNvSpPr txBox="1"/>
+          <p:nvPr/>
+        </p:nvSpPr>
+        <p:spPr>
+          <a:xfrm>
+            <a:off x="6035040" y="274320"/>
+            <a:ext cx="2651760" cy="457200"/>
+          </a:xfrm>
+          <a:prstGeom prst="rect">
+            <a:avLst/>
+          </a:prstGeom>
+          <a:noFill/>
+          <a:ln/>
+        </p:spPr>
+        <p:txBody>
+          <a:bodyPr wrap="square" lIns="0" tIns="0" rIns="0" bIns="0" rtlCol="0" anchor="ctr"/>
+          <a:lstStyle/>
+          <a:p>
+            <a:pPr algn="ctr" indent="0" marL="0">
+              <a:buNone/>
+            </a:pPr>
+            <a:r>
+              <a:rPr lang="en-US" sz="1200" b="1" dirty="0">
+                <a:solidFill>
+                  <a:srgbClr val="FFFFFF"/>
+                </a:solidFill>
+                <a:latin typeface="Calibri" pitchFamily="34" charset="0"/>
+                <a:ea typeface="Calibri" pitchFamily="34" charset="-122"/>
+                <a:cs typeface="Calibri" pitchFamily="34" charset="-120"/>
+              </a:rPr>
+              <a:t>SWITCH TO COPILOT STUDIO</a:t>
+            </a:r>
+            <a:endParaRPr lang="en-US" sz="1200" dirty="0"/>
+          </a:p>
+        </p:txBody>
+      </p:sp>
+      <p:sp>
+        <p:nvSpPr>
+          <p:cNvPr id="7" name="Shape 4"/>
+          <p:cNvSpPr/>
+          <p:nvPr/>
+        </p:nvSpPr>
+        <p:spPr>
+          <a:xfrm>
+            <a:off x="457200" y="1234440"/>
+            <a:ext cx="365760" cy="365760"/>
+          </a:xfrm>
+          <a:prstGeom prst="ellipse">
+            <a:avLst/>
+          </a:prstGeom>
+          <a:solidFill>
+            <a:srgbClr val="00B4D8"/>
+          </a:solidFill>
+          <a:ln w="12700">
+            <a:solidFill>
+              <a:srgbClr val="00B4D8"/>
+            </a:solidFill>
+            <a:prstDash val="solid"/>
+          </a:ln>
+        </p:spPr>
+      </p:sp>
+      <p:sp>
+        <p:nvSpPr>
+          <p:cNvPr id="8" name="Text 5"/>
+          <p:cNvSpPr txBox="1"/>
+          <p:nvPr/>
+        </p:nvSpPr>
+        <p:spPr>
+          <a:xfrm>
+            <a:off x="457200" y="1234440"/>
+            <a:ext cx="365760" cy="365760"/>
+          </a:xfrm>
+          <a:prstGeom prst="rect">
+            <a:avLst/>
+          </a:prstGeom>
+          <a:noFill/>
+          <a:ln/>
+        </p:spPr>
+        <p:txBody>
+          <a:bodyPr wrap="square" lIns="0" tIns="0" rIns="0" bIns="0" rtlCol="0" anchor="ctr"/>
+          <a:lstStyle/>
+          <a:p>
+            <a:pPr algn="ctr" indent="0" marL="0">
+              <a:buNone/>
+            </a:pPr>
+            <a:r>
+              <a:rPr lang="en-US" sz="1400" b="1" dirty="0">
+                <a:solidFill>
+                  <a:srgbClr val="0A1628"/>
+                </a:solidFill>
+                <a:latin typeface="Calibri" pitchFamily="34" charset="0"/>
+                <a:ea typeface="Calibri" pitchFamily="34" charset="-122"/>
+                <a:cs typeface="Calibri" pitchFamily="34" charset="-120"/>
+              </a:rPr>
+              <a:t>1</a:t>
+            </a:r>
+            <a:endParaRPr lang="en-US" sz="1400" dirty="0"/>
+          </a:p>
+        </p:txBody>
+      </p:sp>
+      <p:sp>
+        <p:nvSpPr>
+          <p:cNvPr id="9" name="Text 6"/>
+          <p:cNvSpPr txBox="1"/>
+          <p:nvPr/>
+        </p:nvSpPr>
+        <p:spPr>
+          <a:xfrm>
+            <a:off x="1005840" y="1188720"/>
+            <a:ext cx="7680960" cy="457200"/>
+          </a:xfrm>
+          <a:prstGeom prst="rect">
+            <a:avLst/>
+          </a:prstGeom>
+          <a:noFill/>
+          <a:ln/>
+        </p:spPr>
+        <p:txBody>
+          <a:bodyPr wrap="square" lIns="0" tIns="0" rIns="0" bIns="0" rtlCol="0" anchor="t"/>
+          <a:lstStyle/>
+          <a:p>
+            <a:pPr indent="0" marL="0">
+              <a:buNone/>
+            </a:pPr>
+            <a:r>
+              <a:rPr lang="en-US" sz="1600" b="1" dirty="0">
+                <a:solidFill>
+                  <a:srgbClr val="E8F4FD"/>
+                </a:solidFill>
+                <a:latin typeface="Calibri" pitchFamily="34" charset="0"/>
+                <a:ea typeface="Calibri" pitchFamily="34" charset="-122"/>
+                <a:cs typeface="Calibri" pitchFamily="34" charset="-120"/>
+              </a:rPr>
+              <a:t>Open the agent: Knowledge, Add knowledge</a:t>
+            </a:r>
+            <a:endParaRPr lang="en-US" sz="1600" dirty="0"/>
+          </a:p>
+        </p:txBody>
+      </p:sp>
+      <p:sp>
+        <p:nvSpPr>
+          <p:cNvPr id="10" name="Shape 7"/>
+          <p:cNvSpPr/>
+          <p:nvPr/>
+        </p:nvSpPr>
+        <p:spPr>
+          <a:xfrm>
+            <a:off x="457200" y="1737360"/>
+            <a:ext cx="365760" cy="365760"/>
+          </a:xfrm>
+          <a:prstGeom prst="ellipse">
+            <a:avLst/>
+          </a:prstGeom>
+          <a:solidFill>
+            <a:srgbClr val="00B4D8"/>
+          </a:solidFill>
+          <a:ln w="12700">
+            <a:solidFill>
+              <a:srgbClr val="00B4D8"/>
+            </a:solidFill>
+            <a:prstDash val="solid"/>
+          </a:ln>
+        </p:spPr>
+      </p:sp>
+      <p:sp>
+        <p:nvSpPr>
+          <p:cNvPr id="11" name="Text 8"/>
+          <p:cNvSpPr txBox="1"/>
+          <p:nvPr/>
+        </p:nvSpPr>
+        <p:spPr>
+          <a:xfrm>
+            <a:off x="457200" y="1737360"/>
+            <a:ext cx="365760" cy="365760"/>
+          </a:xfrm>
+          <a:prstGeom prst="rect">
+            <a:avLst/>
+          </a:prstGeom>
+          <a:noFill/>
+          <a:ln/>
+        </p:spPr>
+        <p:txBody>
+          <a:bodyPr wrap="square" lIns="0" tIns="0" rIns="0" bIns="0" rtlCol="0" anchor="ctr"/>
+          <a:lstStyle/>
+          <a:p>
+            <a:pPr algn="ctr" indent="0" marL="0">
+              <a:buNone/>
+            </a:pPr>
+            <a:r>
+              <a:rPr lang="en-US" sz="1400" b="1" dirty="0">
+                <a:solidFill>
+                  <a:srgbClr val="0A1628"/>
+                </a:solidFill>
+                <a:latin typeface="Calibri" pitchFamily="34" charset="0"/>
+                <a:ea typeface="Calibri" pitchFamily="34" charset="-122"/>
+                <a:cs typeface="Calibri" pitchFamily="34" charset="-120"/>
+              </a:rPr>
+              <a:t>2</a:t>
+            </a:r>
+            <a:endParaRPr lang="en-US" sz="1400" dirty="0"/>
+          </a:p>
+        </p:txBody>
+      </p:sp>
+      <p:sp>
+        <p:nvSpPr>
+          <p:cNvPr id="12" name="Text 9"/>
+          <p:cNvSpPr txBox="1"/>
+          <p:nvPr/>
+        </p:nvSpPr>
+        <p:spPr>
+          <a:xfrm>
+            <a:off x="1005840" y="1691640"/>
+            <a:ext cx="7680960" cy="685800"/>
+          </a:xfrm>
+          <a:prstGeom prst="rect">
+            <a:avLst/>
+          </a:prstGeom>
+          <a:noFill/>
+          <a:ln/>
+        </p:spPr>
+        <p:txBody>
+          <a:bodyPr wrap="square" lIns="0" tIns="0" rIns="0" bIns="0" rtlCol="0" anchor="t"/>
+          <a:lstStyle/>
+          <a:p>
+            <a:pPr indent="0" marL="0">
+              <a:buNone/>
+            </a:pPr>
+            <a:r>
+              <a:rPr lang="en-US" sz="1600" b="1" dirty="0">
+                <a:solidFill>
+                  <a:srgbClr val="E8F4FD"/>
+                </a:solidFill>
+                <a:latin typeface="Calibri" pitchFamily="34" charset="0"/>
+                <a:ea typeface="Calibri" pitchFamily="34" charset="-122"/>
+                <a:cs typeface="Calibri" pitchFamily="34" charset="-120"/>
+              </a:rPr>
+              <a:t>Upload AI_Pioneers_Demo_FAQ.docx</a:t>
+            </a:r>
+            <a:endParaRPr lang="en-US" sz="1600" dirty="0"/>
+          </a:p>
+          <a:p>
+            <a:pPr indent="0" marL="0">
+              <a:buNone/>
+            </a:pPr>
+            <a:r>
+              <a:rPr lang="en-US" sz="1300" dirty="0">
+                <a:solidFill>
+                  <a:srgbClr val="90B8D4"/>
+                </a:solidFill>
+                <a:latin typeface="Calibri" pitchFamily="34" charset="0"/>
+                <a:ea typeface="Calibri" pitchFamily="34" charset="-122"/>
+                <a:cs typeface="Calibri" pitchFamily="34" charset="-120"/>
+              </a:rPr>
+              <a:t>Say it is sample content</a:t>
+            </a:r>
+            <a:endParaRPr lang="en-US" sz="1600" dirty="0"/>
+          </a:p>
+        </p:txBody>
+      </p:sp>
+      <p:sp>
+        <p:nvSpPr>
+          <p:cNvPr id="13" name="Shape 10"/>
+          <p:cNvSpPr/>
+          <p:nvPr/>
+        </p:nvSpPr>
+        <p:spPr>
+          <a:xfrm>
+            <a:off x="457200" y="2468880"/>
+            <a:ext cx="365760" cy="365760"/>
+          </a:xfrm>
+          <a:prstGeom prst="ellipse">
+            <a:avLst/>
+          </a:prstGeom>
+          <a:solidFill>
+            <a:srgbClr val="00B4D8"/>
+          </a:solidFill>
+          <a:ln w="12700">
+            <a:solidFill>
+              <a:srgbClr val="00B4D8"/>
+            </a:solidFill>
+            <a:prstDash val="solid"/>
+          </a:ln>
+        </p:spPr>
+      </p:sp>
+      <p:sp>
+        <p:nvSpPr>
+          <p:cNvPr id="14" name="Text 11"/>
+          <p:cNvSpPr txBox="1"/>
+          <p:nvPr/>
+        </p:nvSpPr>
+        <p:spPr>
+          <a:xfrm>
+            <a:off x="457200" y="2468880"/>
+            <a:ext cx="365760" cy="365760"/>
+          </a:xfrm>
+          <a:prstGeom prst="rect">
+            <a:avLst/>
+          </a:prstGeom>
+          <a:noFill/>
+          <a:ln/>
+        </p:spPr>
+        <p:txBody>
+          <a:bodyPr wrap="square" lIns="0" tIns="0" rIns="0" bIns="0" rtlCol="0" anchor="ctr"/>
+          <a:lstStyle/>
+          <a:p>
+            <a:pPr algn="ctr" indent="0" marL="0">
+              <a:buNone/>
+            </a:pPr>
+            <a:r>
+              <a:rPr lang="en-US" sz="1400" b="1" dirty="0">
+                <a:solidFill>
+                  <a:srgbClr val="0A1628"/>
+                </a:solidFill>
+                <a:latin typeface="Calibri" pitchFamily="34" charset="0"/>
+                <a:ea typeface="Calibri" pitchFamily="34" charset="-122"/>
+                <a:cs typeface="Calibri" pitchFamily="34" charset="-120"/>
+              </a:rPr>
+              <a:t>3</a:t>
+            </a:r>
+            <a:endParaRPr lang="en-US" sz="1400" dirty="0"/>
+          </a:p>
+        </p:txBody>
+      </p:sp>
+      <p:sp>
+        <p:nvSpPr>
+          <p:cNvPr id="15" name="Text 12"/>
+          <p:cNvSpPr txBox="1"/>
+          <p:nvPr/>
+        </p:nvSpPr>
+        <p:spPr>
+          <a:xfrm>
+            <a:off x="1005840" y="2423160"/>
+            <a:ext cx="7680960" cy="685800"/>
+          </a:xfrm>
+          <a:prstGeom prst="rect">
+            <a:avLst/>
+          </a:prstGeom>
+          <a:noFill/>
+          <a:ln/>
+        </p:spPr>
+        <p:txBody>
+          <a:bodyPr wrap="square" lIns="0" tIns="0" rIns="0" bIns="0" rtlCol="0" anchor="t"/>
+          <a:lstStyle/>
+          <a:p>
+            <a:pPr indent="0" marL="0">
+              <a:buNone/>
+            </a:pPr>
+            <a:r>
+              <a:rPr lang="en-US" sz="1600" b="1" dirty="0">
+                <a:solidFill>
+                  <a:srgbClr val="E8F4FD"/>
+                </a:solidFill>
+                <a:latin typeface="Calibri" pitchFamily="34" charset="0"/>
+                <a:ea typeface="Calibri" pitchFamily="34" charset="-122"/>
+                <a:cs typeface="Calibri" pitchFamily="34" charset="-120"/>
+              </a:rPr>
+              <a:t>Add public website</a:t>
+            </a:r>
+            <a:endParaRPr lang="en-US" sz="1600" dirty="0"/>
+          </a:p>
+          <a:p>
+            <a:pPr indent="0" marL="0">
+              <a:buNone/>
+            </a:pPr>
+            <a:r>
+              <a:rPr lang="en-US" sz="1300" dirty="0">
+                <a:solidFill>
+                  <a:srgbClr val="90B8D4"/>
+                </a:solidFill>
+                <a:latin typeface="Calibri" pitchFamily="34" charset="0"/>
+                <a:ea typeface="Calibri" pitchFamily="34" charset="-122"/>
+                <a:cs typeface="Calibri" pitchFamily="34" charset="-120"/>
+              </a:rPr>
+              <a:t>https://learn.microsoft.com/microsoft-copilot-studio/</a:t>
+            </a:r>
+            <a:endParaRPr lang="en-US" sz="1600" dirty="0"/>
+          </a:p>
+        </p:txBody>
+      </p:sp>
+      <p:sp>
+        <p:nvSpPr>
+          <p:cNvPr id="16" name="Shape 13"/>
+          <p:cNvSpPr/>
+          <p:nvPr/>
+        </p:nvSpPr>
+        <p:spPr>
+          <a:xfrm>
+            <a:off x="457200" y="3200400"/>
+            <a:ext cx="365760" cy="365760"/>
+          </a:xfrm>
+          <a:prstGeom prst="ellipse">
+            <a:avLst/>
+          </a:prstGeom>
+          <a:solidFill>
+            <a:srgbClr val="00B4D8"/>
+          </a:solidFill>
+          <a:ln w="12700">
+            <a:solidFill>
+              <a:srgbClr val="00B4D8"/>
+            </a:solidFill>
+            <a:prstDash val="solid"/>
+          </a:ln>
+        </p:spPr>
+      </p:sp>
+      <p:sp>
+        <p:nvSpPr>
+          <p:cNvPr id="17" name="Text 14"/>
+          <p:cNvSpPr txBox="1"/>
+          <p:nvPr/>
+        </p:nvSpPr>
+        <p:spPr>
+          <a:xfrm>
+            <a:off x="457200" y="3200400"/>
+            <a:ext cx="365760" cy="365760"/>
+          </a:xfrm>
+          <a:prstGeom prst="rect">
+            <a:avLst/>
+          </a:prstGeom>
+          <a:noFill/>
+          <a:ln/>
+        </p:spPr>
+        <p:txBody>
+          <a:bodyPr wrap="square" lIns="0" tIns="0" rIns="0" bIns="0" rtlCol="0" anchor="ctr"/>
+          <a:lstStyle/>
+          <a:p>
+            <a:pPr algn="ctr" indent="0" marL="0">
+              <a:buNone/>
+            </a:pPr>
+            <a:r>
+              <a:rPr lang="en-US" sz="1400" b="1" dirty="0">
+                <a:solidFill>
+                  <a:srgbClr val="0A1628"/>
+                </a:solidFill>
+                <a:latin typeface="Calibri" pitchFamily="34" charset="0"/>
+                <a:ea typeface="Calibri" pitchFamily="34" charset="-122"/>
+                <a:cs typeface="Calibri" pitchFamily="34" charset="-120"/>
+              </a:rPr>
+              <a:t>4</a:t>
+            </a:r>
+            <a:endParaRPr lang="en-US" sz="1400" dirty="0"/>
+          </a:p>
+        </p:txBody>
+      </p:sp>
+      <p:sp>
+        <p:nvSpPr>
+          <p:cNvPr id="18" name="Text 15"/>
+          <p:cNvSpPr txBox="1"/>
+          <p:nvPr/>
+        </p:nvSpPr>
+        <p:spPr>
+          <a:xfrm>
+            <a:off x="1005840" y="3154680"/>
+            <a:ext cx="7680960" cy="457200"/>
+          </a:xfrm>
+          <a:prstGeom prst="rect">
+            <a:avLst/>
+          </a:prstGeom>
+          <a:noFill/>
+          <a:ln/>
+        </p:spPr>
+        <p:txBody>
+          <a:bodyPr wrap="square" lIns="0" tIns="0" rIns="0" bIns="0" rtlCol="0" anchor="t"/>
+          <a:lstStyle/>
+          <a:p>
+            <a:pPr indent="0" marL="0">
+              <a:buNone/>
+            </a:pPr>
+            <a:r>
+              <a:rPr lang="en-US" sz="1600" b="1" dirty="0">
+                <a:solidFill>
+                  <a:srgbClr val="E8F4FD"/>
+                </a:solidFill>
+                <a:latin typeface="Calibri" pitchFamily="34" charset="0"/>
+                <a:ea typeface="Calibri" pitchFamily="34" charset="-122"/>
+                <a:cs typeface="Calibri" pitchFamily="34" charset="-120"/>
+              </a:rPr>
+              <a:t>Wait until both sources show Ready</a:t>
+            </a:r>
+            <a:endParaRPr lang="en-US" sz="1600" dirty="0"/>
+          </a:p>
+        </p:txBody>
+      </p:sp>
+      <p:sp>
+        <p:nvSpPr>
+          <p:cNvPr id="19" name="Text 16"/>
+          <p:cNvSpPr txBox="1"/>
+          <p:nvPr/>
+        </p:nvSpPr>
+        <p:spPr>
+          <a:xfrm>
+            <a:off x="457200" y="4572000"/>
+            <a:ext cx="8229600" cy="274320"/>
+          </a:xfrm>
+          <a:prstGeom prst="rect">
+            <a:avLst/>
+          </a:prstGeom>
+          <a:noFill/>
+          <a:ln/>
+        </p:spPr>
+        <p:txBody>
+          <a:bodyPr wrap="square" lIns="0" tIns="0" rIns="0" bIns="0" rtlCol="0" anchor="ctr"/>
+          <a:lstStyle/>
+          <a:p>
+            <a:pPr indent="0" marL="0">
+              <a:buNone/>
+            </a:pPr>
+            <a:r>
+              <a:rPr lang="en-US" sz="1200" i="1" dirty="0">
+                <a:solidFill>
+                  <a:srgbClr val="90B8D4"/>
+                </a:solidFill>
+                <a:latin typeface="Calibri" pitchFamily="34" charset="0"/>
+                <a:ea typeface="Calibri" pitchFamily="34" charset="-122"/>
+                <a:cs typeface="Calibri" pitchFamily="34" charset="-120"/>
+              </a:rPr>
+              <a:t>Then return to the slides</a:t>
+            </a:r>
+            <a:endParaRPr lang="en-US" sz="1200" dirty="0"/>
+          </a:p>
+        </p:txBody>
+      </p:sp>
+    </p:spTree>
+  </p:cSld>
+  <p:clrMapOvr>
+    <a:masterClrMapping/>
+  </p:clrMapOvr>
+</p:sld>
+</file>
+
+<file path=ppt/slides/slide9.xml><?xml version="1.0" encoding="utf-8"?>
+<p:sld xmlns:a="http://schemas.openxmlformats.org/drawingml/2006/main" xmlns:r="http://schemas.openxmlformats.org/officeDocument/2006/relationships" xmlns:p="http://schemas.openxmlformats.org/presentationml/2006/main">
+  <p:cSld name="Slide 9">
+    <p:bg>
+      <p:bgPr>
+        <a:solidFill>
+          <a:srgbClr val="0A1628"/>
+        </a:solidFill>
+      </p:bgPr>
+    </p:bg>
+    <p:spTree>
+      <p:nvGrpSpPr>
+        <p:cNvPr id="1" name=""/>
+        <p:cNvGrpSpPr/>
+        <p:nvPr/>
+      </p:nvGrpSpPr>
+      <p:grpSpPr>
+        <a:xfrm>
+          <a:off x="0" y="0"/>
+          <a:ext cx="0" cy="0"/>
+          <a:chOff x="0" y="0"/>
+          <a:chExt cx="0" cy="0"/>
+        </a:xfrm>
+      </p:grpSpPr>
+      <p:sp>
+        <p:nvSpPr>
+          <p:cNvPr id="2" name="Text 0"/>
+          <p:cNvSpPr txBox="1"/>
+          <p:nvPr/>
+        </p:nvSpPr>
+        <p:spPr>
+          <a:xfrm>
+            <a:off x="457200" y="274320"/>
+            <a:ext cx="8229600" cy="548640"/>
+          </a:xfrm>
+          <a:prstGeom prst="rect">
+            <a:avLst/>
+          </a:prstGeom>
+          <a:noFill/>
+          <a:ln/>
+        </p:spPr>
+        <p:txBody>
+          <a:bodyPr wrap="square" lIns="0" tIns="0" rIns="0" bIns="0" rtlCol="0" anchor="ctr"/>
+          <a:lstStyle/>
+          <a:p>
+            <a:pPr indent="0" marL="0">
+              <a:buNone/>
+            </a:pPr>
+            <a:r>
+              <a:rPr lang="en-US" sz="2800" b="1" dirty="0">
+                <a:solidFill>
+                  <a:srgbClr val="FFFFFF"/>
+                </a:solidFill>
+                <a:latin typeface="Calibri" pitchFamily="34" charset="0"/>
+                <a:ea typeface="Calibri" pitchFamily="34" charset="-122"/>
+                <a:cs typeface="Calibri" pitchFamily="34" charset="-120"/>
+              </a:rPr>
+              <a:t>Test it: refusals too</a:t>
+            </a:r>
+            <a:endParaRPr lang="en-US" sz="2800" dirty="0"/>
+          </a:p>
+        </p:txBody>
+      </p:sp>
+      <p:sp>
+        <p:nvSpPr>
+          <p:cNvPr id="3" name="Shape 1"/>
+          <p:cNvSpPr/>
+          <p:nvPr/>
+        </p:nvSpPr>
+        <p:spPr>
+          <a:xfrm>
+            <a:off x="457200" y="868680"/>
+            <a:ext cx="1097280" cy="54864"/>
+          </a:xfrm>
+          <a:prstGeom prst="rect">
+            <a:avLst/>
+          </a:prstGeom>
+          <a:solidFill>
+            <a:srgbClr val="00B4D8"/>
+          </a:solidFill>
+          <a:ln w="12700">
+            <a:solidFill>
+              <a:srgbClr val="00B4D8"/>
+            </a:solidFill>
+            <a:prstDash val="solid"/>
+          </a:ln>
+        </p:spPr>
+      </p:sp>
+      <p:sp>
+        <p:nvSpPr>
+          <p:cNvPr id="5" name="Shape 2"/>
+          <p:cNvSpPr/>
+          <p:nvPr/>
+        </p:nvSpPr>
+        <p:spPr>
+          <a:xfrm>
             <a:off x="457200" y="1188720"/>
-            <a:ext cx="1828800" cy="2103120"/>
+            <a:ext cx="3931920" cy="1463040"/>
+          </a:xfrm>
+          <a:prstGeom prst="rect">
+            <a:avLst/>
+          </a:prstGeom>
+          <a:solidFill>
+            <a:srgbClr val="102235"/>
+          </a:solidFill>
+          <a:ln w="19050">
+            <a:solidFill>
+              <a:srgbClr val="4CAF82"/>
+            </a:solidFill>
+            <a:prstDash val="solid"/>
+          </a:ln>
+        </p:spPr>
+      </p:sp>
+      <p:sp>
+        <p:nvSpPr>
+          <p:cNvPr id="6" name="Text 3"/>
+          <p:cNvSpPr txBox="1"/>
+          <p:nvPr/>
+        </p:nvSpPr>
+        <p:spPr>
+          <a:xfrm>
+            <a:off x="640080" y="1325880"/>
+            <a:ext cx="3566160" cy="457200"/>
+          </a:xfrm>
+          <a:prstGeom prst="rect">
+            <a:avLst/>
+          </a:prstGeom>
+          <a:noFill/>
+          <a:ln/>
+        </p:spPr>
+        <p:txBody>
+          <a:bodyPr wrap="square" lIns="0" tIns="0" rIns="0" bIns="0" rtlCol="0" anchor="t"/>
+          <a:lstStyle/>
+          <a:p>
+            <a:pPr indent="0" marL="0">
+              <a:buNone/>
+            </a:pPr>
+            <a:r>
+              <a:rPr lang="en-US" sz="2000" b="1" dirty="0">
+                <a:solidFill>
+                  <a:srgbClr val="4CAF82"/>
+                </a:solidFill>
+                <a:latin typeface="Calibri" pitchFamily="34" charset="0"/>
+                <a:ea typeface="Calibri" pitchFamily="34" charset="-122"/>
+                <a:cs typeface="Calibri" pitchFamily="34" charset="-120"/>
+              </a:rPr>
+              <a:t>From the document</a:t>
+            </a:r>
+            <a:endParaRPr lang="en-US" sz="2000" dirty="0"/>
+          </a:p>
+        </p:txBody>
+      </p:sp>
+      <p:sp>
+        <p:nvSpPr>
+          <p:cNvPr id="7" name="Text 4"/>
+          <p:cNvSpPr txBox="1"/>
+          <p:nvPr/>
+        </p:nvSpPr>
+        <p:spPr>
+          <a:xfrm>
+            <a:off x="640080" y="1874520"/>
+            <a:ext cx="3566160" cy="594360"/>
+          </a:xfrm>
+          <a:prstGeom prst="rect">
+            <a:avLst/>
+          </a:prstGeom>
+          <a:noFill/>
+          <a:ln/>
+        </p:spPr>
+        <p:txBody>
+          <a:bodyPr wrap="square" lIns="0" tIns="0" rIns="0" bIns="0" rtlCol="0" anchor="t"/>
+          <a:lstStyle/>
+          <a:p>
+            <a:pPr indent="0" marL="0">
+              <a:buNone/>
+            </a:pPr>
+            <a:r>
+              <a:rPr lang="en-US" sz="1600" dirty="0">
+                <a:solidFill>
+                  <a:srgbClr val="E8F4FD"/>
+                </a:solidFill>
+                <a:latin typeface="Calibri" pitchFamily="34" charset="0"/>
+                <a:ea typeface="Calibri" pitchFamily="34" charset="-122"/>
+                <a:cs typeface="Calibri" pitchFamily="34" charset="-120"/>
+              </a:rPr>
+              <a:t>How is each session structured?</a:t>
+            </a:r>
+            <a:endParaRPr lang="en-US" sz="1600" dirty="0"/>
+          </a:p>
+        </p:txBody>
+      </p:sp>
+      <p:sp>
+        <p:nvSpPr>
+          <p:cNvPr id="8" name="Shape 5"/>
+          <p:cNvSpPr/>
+          <p:nvPr/>
+        </p:nvSpPr>
+        <p:spPr>
+          <a:xfrm>
+            <a:off x="4754880" y="1188720"/>
+            <a:ext cx="3931920" cy="1463040"/>
+          </a:xfrm>
+          <a:prstGeom prst="rect">
+            <a:avLst/>
+          </a:prstGeom>
+          <a:solidFill>
+            <a:srgbClr val="102235"/>
+          </a:solidFill>
+          <a:ln w="19050">
+            <a:solidFill>
+              <a:srgbClr val="00B4D8"/>
+            </a:solidFill>
+            <a:prstDash val="solid"/>
+          </a:ln>
+        </p:spPr>
+      </p:sp>
+      <p:sp>
+        <p:nvSpPr>
+          <p:cNvPr id="9" name="Text 6"/>
+          <p:cNvSpPr txBox="1"/>
+          <p:nvPr/>
+        </p:nvSpPr>
+        <p:spPr>
+          <a:xfrm>
+            <a:off x="4937760" y="1325880"/>
+            <a:ext cx="3566160" cy="457200"/>
+          </a:xfrm>
+          <a:prstGeom prst="rect">
+            <a:avLst/>
+          </a:prstGeom>
+          <a:noFill/>
+          <a:ln/>
+        </p:spPr>
+        <p:txBody>
+          <a:bodyPr wrap="square" lIns="0" tIns="0" rIns="0" bIns="0" rtlCol="0" anchor="t"/>
+          <a:lstStyle/>
+          <a:p>
+            <a:pPr indent="0" marL="0">
+              <a:buNone/>
+            </a:pPr>
+            <a:r>
+              <a:rPr lang="en-US" sz="2000" b="1" dirty="0">
+                <a:solidFill>
+                  <a:srgbClr val="00B4D8"/>
+                </a:solidFill>
+                <a:latin typeface="Calibri" pitchFamily="34" charset="0"/>
+                <a:ea typeface="Calibri" pitchFamily="34" charset="-122"/>
+                <a:cs typeface="Calibri" pitchFamily="34" charset="-120"/>
+              </a:rPr>
+              <a:t>From the website</a:t>
+            </a:r>
+            <a:endParaRPr lang="en-US" sz="2000" dirty="0"/>
+          </a:p>
+        </p:txBody>
+      </p:sp>
+      <p:sp>
+        <p:nvSpPr>
+          <p:cNvPr id="10" name="Text 7"/>
+          <p:cNvSpPr txBox="1"/>
+          <p:nvPr/>
+        </p:nvSpPr>
+        <p:spPr>
+          <a:xfrm>
+            <a:off x="4937760" y="1874520"/>
+            <a:ext cx="3566160" cy="594360"/>
+          </a:xfrm>
+          <a:prstGeom prst="rect">
+            <a:avLst/>
+          </a:prstGeom>
+          <a:noFill/>
+          <a:ln/>
+        </p:spPr>
+        <p:txBody>
+          <a:bodyPr wrap="square" lIns="0" tIns="0" rIns="0" bIns="0" rtlCol="0" anchor="t"/>
+          <a:lstStyle/>
+          <a:p>
+            <a:pPr indent="0" marL="0">
+              <a:buNone/>
+            </a:pPr>
+            <a:r>
+              <a:rPr lang="en-US" sz="1600" dirty="0">
+                <a:solidFill>
+                  <a:srgbClr val="E8F4FD"/>
+                </a:solidFill>
+                <a:latin typeface="Calibri" pitchFamily="34" charset="0"/>
+                <a:ea typeface="Calibri" pitchFamily="34" charset="-122"/>
+                <a:cs typeface="Calibri" pitchFamily="34" charset="-120"/>
+              </a:rPr>
+              <a:t>How do I add a public website as knowledge?</a:t>
+            </a:r>
+            <a:endParaRPr lang="en-US" sz="1600" dirty="0"/>
+          </a:p>
+        </p:txBody>
+      </p:sp>
+      <p:sp>
+        <p:nvSpPr>
+          <p:cNvPr id="11" name="Shape 8"/>
+          <p:cNvSpPr/>
+          <p:nvPr/>
+        </p:nvSpPr>
+        <p:spPr>
+          <a:xfrm>
+            <a:off x="457200" y="2926080"/>
+            <a:ext cx="3931920" cy="1463040"/>
           </a:xfrm>
           <a:prstGeom prst="rect">
             <a:avLst/>
@@ -4603,14 +7281,14 @@
       </p:sp>
       <p:sp>
         <p:nvSpPr>
-          <p:cNvPr id="6" name="Text 3"/>
-          <p:cNvSpPr txBox="1"/>
-          <p:nvPr/>
-        </p:nvSpPr>
-        <p:spPr>
-          <a:xfrm>
-            <a:off x="640080" y="1325880"/>
-            <a:ext cx="1463040" cy="457200"/>
+          <p:cNvPr id="12" name="Text 9"/>
+          <p:cNvSpPr txBox="1"/>
+          <p:nvPr/>
+        </p:nvSpPr>
+        <p:spPr>
+          <a:xfrm>
+            <a:off x="640080" y="3063240"/>
+            <a:ext cx="3566160" cy="457200"/>
           </a:xfrm>
           <a:prstGeom prst="rect">
             <a:avLst/>
@@ -4634,7 +7312,7 @@
                 <a:ea typeface="Calibri" pitchFamily="34" charset="-122"/>
                 <a:cs typeface="Calibri" pitchFamily="34" charset="-120"/>
               </a:rPr>
-              <a:t>Poor retrieval</a:t>
+              <a:t>Not in any source</a:t>
             </a:r>
             <a:endParaRPr lang="en-US" sz="2000" dirty="0"/>
           </a:p>
@@ -4642,14 +7320,14 @@
       </p:sp>
       <p:sp>
         <p:nvSpPr>
-          <p:cNvPr id="7" name="Text 4"/>
-          <p:cNvSpPr txBox="1"/>
-          <p:nvPr/>
-        </p:nvSpPr>
-        <p:spPr>
-          <a:xfrm>
-            <a:off x="640080" y="1874520"/>
-            <a:ext cx="1463040" cy="1234440"/>
+          <p:cNvPr id="13" name="Text 10"/>
+          <p:cNvSpPr txBox="1"/>
+          <p:nvPr/>
+        </p:nvSpPr>
+        <p:spPr>
+          <a:xfrm>
+            <a:off x="640080" y="3611880"/>
+            <a:ext cx="3566160" cy="594360"/>
           </a:xfrm>
           <a:prstGeom prst="rect">
             <a:avLst/>
@@ -4673,7 +7351,7 @@
                 <a:ea typeface="Calibri" pitchFamily="34" charset="-122"/>
                 <a:cs typeface="Calibri" pitchFamily="34" charset="-120"/>
               </a:rPr>
-              <a:t>Wrong passage found</a:t>
+              <a:t>How much does it cost? Must decline</a:t>
             </a:r>
             <a:endParaRPr lang="en-US" sz="1600" dirty="0"/>
           </a:p>
@@ -4681,14 +7359,14 @@
       </p:sp>
       <p:sp>
         <p:nvSpPr>
-          <p:cNvPr id="8" name="Shape 5"/>
+          <p:cNvPr id="14" name="Shape 11"/>
           <p:cNvSpPr/>
           <p:nvPr/>
         </p:nvSpPr>
         <p:spPr>
           <a:xfrm>
-            <a:off x="2423160" y="1188720"/>
-            <a:ext cx="1828800" cy="2103120"/>
+            <a:off x="4754880" y="2926080"/>
+            <a:ext cx="3931920" cy="1463040"/>
           </a:xfrm>
           <a:prstGeom prst="rect">
             <a:avLst/>
@@ -4698,7 +7376,7 @@
           </a:solidFill>
           <a:ln w="19050">
             <a:solidFill>
-              <a:srgbClr val="FF6B35"/>
+              <a:srgbClr val="9B72CF"/>
             </a:solidFill>
             <a:prstDash val="solid"/>
           </a:ln>
@@ -4706,14 +7384,14 @@
       </p:sp>
       <p:sp>
         <p:nvSpPr>
-          <p:cNvPr id="9" name="Text 6"/>
-          <p:cNvSpPr txBox="1"/>
-          <p:nvPr/>
-        </p:nvSpPr>
-        <p:spPr>
-          <a:xfrm>
-            <a:off x="2606040" y="1325880"/>
-            <a:ext cx="1463040" cy="457200"/>
+          <p:cNvPr id="15" name="Text 12"/>
+          <p:cNvSpPr txBox="1"/>
+          <p:nvPr/>
+        </p:nvSpPr>
+        <p:spPr>
+          <a:xfrm>
+            <a:off x="4937760" y="3063240"/>
+            <a:ext cx="3566160" cy="457200"/>
           </a:xfrm>
           <a:prstGeom prst="rect">
             <a:avLst/>
@@ -4731,13 +7409,13 @@
             <a:r>
               <a:rPr lang="en-US" sz="2000" b="1" dirty="0">
                 <a:solidFill>
-                  <a:srgbClr val="FF6B35"/>
-                </a:solidFill>
-                <a:latin typeface="Calibri" pitchFamily="34" charset="0"/>
-                <a:ea typeface="Calibri" pitchFamily="34" charset="-122"/>
-                <a:cs typeface="Calibri" pitchFamily="34" charset="-120"/>
-              </a:rPr>
-              <a:t>Stale sources</a:t>
+                  <a:srgbClr val="9B72CF"/>
+                </a:solidFill>
+                <a:latin typeface="Calibri" pitchFamily="34" charset="0"/>
+                <a:ea typeface="Calibri" pitchFamily="34" charset="-122"/>
+                <a:cs typeface="Calibri" pitchFamily="34" charset="-120"/>
+              </a:rPr>
+              <a:t>Out of scope</a:t>
             </a:r>
             <a:endParaRPr lang="en-US" sz="2000" dirty="0"/>
           </a:p>
@@ -4745,14 +7423,14 @@
       </p:sp>
       <p:sp>
         <p:nvSpPr>
-          <p:cNvPr id="10" name="Text 7"/>
-          <p:cNvSpPr txBox="1"/>
-          <p:nvPr/>
-        </p:nvSpPr>
-        <p:spPr>
-          <a:xfrm>
-            <a:off x="2606040" y="1874520"/>
-            <a:ext cx="1463040" cy="1234440"/>
+          <p:cNvPr id="16" name="Text 13"/>
+          <p:cNvSpPr txBox="1"/>
+          <p:nvPr/>
+        </p:nvSpPr>
+        <p:spPr>
+          <a:xfrm>
+            <a:off x="4937760" y="3611880"/>
+            <a:ext cx="3566160" cy="594360"/>
           </a:xfrm>
           <a:prstGeom prst="rect">
             <a:avLst/>
@@ -4776,277 +7454,7 @@
                 <a:ea typeface="Calibri" pitchFamily="34" charset="-122"/>
                 <a:cs typeface="Calibri" pitchFamily="34" charset="-120"/>
               </a:rPr>
-              <a:t>Someone must own updates</a:t>
-            </a:r>
-            <a:endParaRPr lang="en-US" sz="1600" dirty="0"/>
-          </a:p>
-        </p:txBody>
-      </p:sp>
-      <p:sp>
-        <p:nvSpPr>
-          <p:cNvPr id="11" name="Shape 8"/>
-          <p:cNvSpPr/>
-          <p:nvPr/>
-        </p:nvSpPr>
-        <p:spPr>
-          <a:xfrm>
-            <a:off x="4389120" y="1188720"/>
-            <a:ext cx="1828800" cy="2103120"/>
-          </a:xfrm>
-          <a:prstGeom prst="rect">
-            <a:avLst/>
-          </a:prstGeom>
-          <a:solidFill>
-            <a:srgbClr val="102235"/>
-          </a:solidFill>
-          <a:ln w="19050">
-            <a:solidFill>
-              <a:srgbClr val="FF6B35"/>
-            </a:solidFill>
-            <a:prstDash val="solid"/>
-          </a:ln>
-        </p:spPr>
-      </p:sp>
-      <p:sp>
-        <p:nvSpPr>
-          <p:cNvPr id="12" name="Text 9"/>
-          <p:cNvSpPr txBox="1"/>
-          <p:nvPr/>
-        </p:nvSpPr>
-        <p:spPr>
-          <a:xfrm>
-            <a:off x="4572000" y="1325880"/>
-            <a:ext cx="1463040" cy="457200"/>
-          </a:xfrm>
-          <a:prstGeom prst="rect">
-            <a:avLst/>
-          </a:prstGeom>
-          <a:noFill/>
-          <a:ln/>
-        </p:spPr>
-        <p:txBody>
-          <a:bodyPr wrap="square" lIns="0" tIns="0" rIns="0" bIns="0" rtlCol="0" anchor="t"/>
-          <a:lstStyle/>
-          <a:p>
-            <a:pPr indent="0" marL="0">
-              <a:buNone/>
-            </a:pPr>
-            <a:r>
-              <a:rPr lang="en-US" sz="2000" b="1" dirty="0">
-                <a:solidFill>
-                  <a:srgbClr val="FF6B35"/>
-                </a:solidFill>
-                <a:latin typeface="Calibri" pitchFamily="34" charset="0"/>
-                <a:ea typeface="Calibri" pitchFamily="34" charset="-122"/>
-                <a:cs typeface="Calibri" pitchFamily="34" charset="-120"/>
-              </a:rPr>
-              <a:t>Conflicts</a:t>
-            </a:r>
-            <a:endParaRPr lang="en-US" sz="2000" dirty="0"/>
-          </a:p>
-        </p:txBody>
-      </p:sp>
-      <p:sp>
-        <p:nvSpPr>
-          <p:cNvPr id="13" name="Text 10"/>
-          <p:cNvSpPr txBox="1"/>
-          <p:nvPr/>
-        </p:nvSpPr>
-        <p:spPr>
-          <a:xfrm>
-            <a:off x="4572000" y="1874520"/>
-            <a:ext cx="1463040" cy="1234440"/>
-          </a:xfrm>
-          <a:prstGeom prst="rect">
-            <a:avLst/>
-          </a:prstGeom>
-          <a:noFill/>
-          <a:ln/>
-        </p:spPr>
-        <p:txBody>
-          <a:bodyPr wrap="square" lIns="0" tIns="0" rIns="0" bIns="0" rtlCol="0" anchor="t"/>
-          <a:lstStyle/>
-          <a:p>
-            <a:pPr indent="0" marL="0">
-              <a:buNone/>
-            </a:pPr>
-            <a:r>
-              <a:rPr lang="en-US" sz="1600" dirty="0">
-                <a:solidFill>
-                  <a:srgbClr val="E8F4FD"/>
-                </a:solidFill>
-                <a:latin typeface="Calibri" pitchFamily="34" charset="0"/>
-                <a:ea typeface="Calibri" pitchFamily="34" charset="-122"/>
-                <a:cs typeface="Calibri" pitchFamily="34" charset="-120"/>
-              </a:rPr>
-              <a:t>Decide which source wins</a:t>
-            </a:r>
-            <a:endParaRPr lang="en-US" sz="1600" dirty="0"/>
-          </a:p>
-        </p:txBody>
-      </p:sp>
-      <p:sp>
-        <p:nvSpPr>
-          <p:cNvPr id="14" name="Shape 11"/>
-          <p:cNvSpPr/>
-          <p:nvPr/>
-        </p:nvSpPr>
-        <p:spPr>
-          <a:xfrm>
-            <a:off x="6355080" y="1188720"/>
-            <a:ext cx="2331720" cy="2103120"/>
-          </a:xfrm>
-          <a:prstGeom prst="rect">
-            <a:avLst/>
-          </a:prstGeom>
-          <a:solidFill>
-            <a:srgbClr val="102235"/>
-          </a:solidFill>
-          <a:ln w="19050">
-            <a:solidFill>
-              <a:srgbClr val="FF6B35"/>
-            </a:solidFill>
-            <a:prstDash val="solid"/>
-          </a:ln>
-        </p:spPr>
-      </p:sp>
-      <p:sp>
-        <p:nvSpPr>
-          <p:cNvPr id="15" name="Text 12"/>
-          <p:cNvSpPr txBox="1"/>
-          <p:nvPr/>
-        </p:nvSpPr>
-        <p:spPr>
-          <a:xfrm>
-            <a:off x="6537960" y="1325880"/>
-            <a:ext cx="1965960" cy="457200"/>
-          </a:xfrm>
-          <a:prstGeom prst="rect">
-            <a:avLst/>
-          </a:prstGeom>
-          <a:noFill/>
-          <a:ln/>
-        </p:spPr>
-        <p:txBody>
-          <a:bodyPr wrap="square" lIns="0" tIns="0" rIns="0" bIns="0" rtlCol="0" anchor="t"/>
-          <a:lstStyle/>
-          <a:p>
-            <a:pPr indent="0" marL="0">
-              <a:buNone/>
-            </a:pPr>
-            <a:r>
-              <a:rPr lang="en-US" sz="2000" b="1" dirty="0">
-                <a:solidFill>
-                  <a:srgbClr val="FF6B35"/>
-                </a:solidFill>
-                <a:latin typeface="Calibri" pitchFamily="34" charset="0"/>
-                <a:ea typeface="Calibri" pitchFamily="34" charset="-122"/>
-                <a:cs typeface="Calibri" pitchFamily="34" charset="-120"/>
-              </a:rPr>
-              <a:t>Setting clash</a:t>
-            </a:r>
-            <a:endParaRPr lang="en-US" sz="2000" dirty="0"/>
-          </a:p>
-        </p:txBody>
-      </p:sp>
-      <p:sp>
-        <p:nvSpPr>
-          <p:cNvPr id="16" name="Text 13"/>
-          <p:cNvSpPr txBox="1"/>
-          <p:nvPr/>
-        </p:nvSpPr>
-        <p:spPr>
-          <a:xfrm>
-            <a:off x="6537960" y="1874520"/>
-            <a:ext cx="1965960" cy="1234440"/>
-          </a:xfrm>
-          <a:prstGeom prst="rect">
-            <a:avLst/>
-          </a:prstGeom>
-          <a:noFill/>
-          <a:ln/>
-        </p:spPr>
-        <p:txBody>
-          <a:bodyPr wrap="square" lIns="0" tIns="0" rIns="0" bIns="0" rtlCol="0" anchor="t"/>
-          <a:lstStyle/>
-          <a:p>
-            <a:pPr indent="0" marL="0">
-              <a:buNone/>
-            </a:pPr>
-            <a:r>
-              <a:rPr lang="en-US" sz="1600" dirty="0">
-                <a:solidFill>
-                  <a:srgbClr val="E8F4FD"/>
-                </a:solidFill>
-                <a:latin typeface="Calibri" pitchFamily="34" charset="0"/>
-                <a:ea typeface="Calibri" pitchFamily="34" charset="-122"/>
-                <a:cs typeface="Calibri" pitchFamily="34" charset="-120"/>
-              </a:rPr>
-              <a:t>Instructions vs web search</a:t>
-            </a:r>
-            <a:endParaRPr lang="en-US" sz="1600" dirty="0"/>
-          </a:p>
-        </p:txBody>
-      </p:sp>
-      <p:sp>
-        <p:nvSpPr>
-          <p:cNvPr id="17" name="Shape 14"/>
-          <p:cNvSpPr/>
-          <p:nvPr/>
-        </p:nvSpPr>
-        <p:spPr>
-          <a:xfrm>
-            <a:off x="457200" y="3566160"/>
-            <a:ext cx="8229600" cy="1005840"/>
-          </a:xfrm>
-          <a:prstGeom prst="rect">
-            <a:avLst/>
-          </a:prstGeom>
-          <a:solidFill>
-            <a:srgbClr val="0D2137"/>
-          </a:solidFill>
-          <a:ln w="19050">
-            <a:solidFill>
-              <a:srgbClr val="00B4D8"/>
-            </a:solidFill>
-            <a:prstDash val="solid"/>
-          </a:ln>
-        </p:spPr>
-      </p:sp>
-      <p:sp>
-        <p:nvSpPr>
-          <p:cNvPr id="18" name="Text 15"/>
-          <p:cNvSpPr txBox="1"/>
-          <p:nvPr/>
-        </p:nvSpPr>
-        <p:spPr>
-          <a:xfrm>
-            <a:off x="640080" y="3749040"/>
-            <a:ext cx="7863840" cy="640080"/>
-          </a:xfrm>
-          <a:prstGeom prst="rect">
-            <a:avLst/>
-          </a:prstGeom>
-          <a:noFill/>
-          <a:ln/>
-        </p:spPr>
-        <p:txBody>
-          <a:bodyPr wrap="square" lIns="0" tIns="0" rIns="0" bIns="0" rtlCol="0" anchor="ctr"/>
-          <a:lstStyle/>
-          <a:p>
-            <a:pPr algn="ctr" indent="0" marL="0">
-              <a:buNone/>
-            </a:pPr>
-            <a:r>
-              <a:rPr lang="en-US" sz="1600" b="1" dirty="0">
-                <a:solidFill>
-                  <a:srgbClr val="00B4D8"/>
-                </a:solidFill>
-                <a:latin typeface="Calibri" pitchFamily="34" charset="0"/>
-                <a:ea typeface="Calibri" pitchFamily="34" charset="-122"/>
-                <a:cs typeface="Calibri" pitchFamily="34" charset="-120"/>
-              </a:rPr>
-              <a:t>Retrieve, augment, generate  •  Good sources plus clear instructions  •  Test refusals</a:t>
+              <a:t>A political question. Must decline</a:t>
             </a:r>
             <a:endParaRPr lang="en-US" sz="1600" dirty="0"/>
           </a:p>

</xml_diff>